<commit_message>
Add lyre string and load evidence gates
</commit_message>
<xml_diff>
--- a/capstone-deck.pptx
+++ b/capstone-deck.pptx
@@ -10,16 +10,8 @@
     <p:sldId id="258" r:id="rId9"/>
     <p:sldId id="259" r:id="rId10"/>
     <p:sldId id="260" r:id="rId11"/>
-    <p:sldId id="261" r:id="rId12"/>
-    <p:sldId id="262" r:id="rId13"/>
-    <p:sldId id="263" r:id="rId14"/>
-    <p:sldId id="264" r:id="rId15"/>
-    <p:sldId id="265" r:id="rId16"/>
-    <p:sldId id="266" r:id="rId17"/>
-    <p:sldId id="267" r:id="rId18"/>
-    <p:sldId id="268" r:id="rId19"/>
   </p:sldIdLst>
-  <p:sldSz cx="12191695" cy="6858000" type="screen4x3"/>
+  <p:sldSz cx="9144000" cy="6858000" type="screen4x3"/>
   <p:notesSz cx="6858000" cy="9144000"/>
   <p:defaultTextStyle>
     <a:defPPr>
@@ -3102,992 +3094,61 @@
       <p:grpSpPr/>
       <p:sp>
         <p:nvSpPr>
-          <p:cNvPr id="2" name="Rectangle 1"/>
-          <p:cNvSpPr/>
-          <p:nvPr/>
-        </p:nvSpPr>
-        <p:spPr>
-          <a:xfrm>
-            <a:off x="0" y="0"/>
-            <a:ext cx="12191695" cy="411480"/>
-          </a:xfrm>
-          <a:prstGeom prst="rect">
-            <a:avLst/>
-          </a:prstGeom>
-          <a:solidFill>
-            <a:srgbClr val="1F3A68"/>
-          </a:solidFill>
-          <a:ln>
-            <a:noFill/>
-          </a:ln>
-        </p:spPr>
-        <p:style>
-          <a:lnRef idx="1">
-            <a:schemeClr val="accent1"/>
-          </a:lnRef>
-          <a:fillRef idx="3">
-            <a:schemeClr val="accent1"/>
-          </a:fillRef>
-          <a:effectRef idx="2">
-            <a:schemeClr val="accent1"/>
-          </a:effectRef>
-          <a:fontRef idx="minor">
-            <a:schemeClr val="lt1"/>
-          </a:fontRef>
-        </p:style>
-        <p:txBody>
-          <a:bodyPr rtlCol="0" anchor="ctr"/>
-          <a:lstStyle/>
-          <a:p>
-            <a:pPr algn="ctr"/>
-          </a:p>
-        </p:txBody>
-      </p:sp>
-      <p:sp>
-        <p:nvSpPr>
-          <p:cNvPr id="3" name="TextBox 2"/>
-          <p:cNvSpPr txBox="1"/>
-          <p:nvPr/>
-        </p:nvSpPr>
-        <p:spPr>
-          <a:xfrm>
-            <a:off x="457200" y="548640"/>
-            <a:ext cx="11247120" cy="914400"/>
-          </a:xfrm>
-          <a:prstGeom prst="rect">
-            <a:avLst/>
-          </a:prstGeom>
-          <a:noFill/>
-        </p:spPr>
-        <p:txBody>
-          <a:bodyPr wrap="square">
-            <a:spAutoFit/>
-          </a:bodyPr>
+          <p:cNvPr id="2" name="Title 1"/>
+          <p:cNvSpPr>
+            <a:spLocks noGrp="1"/>
+          </p:cNvSpPr>
+          <p:nvPr>
+            <p:ph type="title"/>
+          </p:nvPr>
+        </p:nvSpPr>
+        <p:spPr/>
+        <p:txBody>
+          <a:bodyPr/>
+          <a:lstStyle/>
+          <a:p>
+            <a:r>
+              <a:t>Lyre Build Packet</a:t>
+            </a:r>
+          </a:p>
+        </p:txBody>
+      </p:sp>
+      <p:sp>
+        <p:nvSpPr>
+          <p:cNvPr id="3" name="Content Placeholder 2"/>
+          <p:cNvSpPr>
+            <a:spLocks noGrp="1"/>
+          </p:cNvSpPr>
+          <p:nvPr>
+            <p:ph idx="1"/>
+          </p:nvPr>
+        </p:nvSpPr>
+        <p:spPr/>
+        <p:txBody>
+          <a:bodyPr/>
           <a:lstStyle/>
           <a:p>
             <a:pPr>
-              <a:defRPr sz="3600" b="1">
-                <a:solidFill>
-                  <a:srgbClr val="1F3A68"/>
-                </a:solidFill>
-              </a:defRPr>
+              <a:defRPr sz="2000"/>
             </a:pPr>
             <a:r>
-              <a:t>Lyre Build Packet</a:t>
-            </a:r>
-          </a:p>
-        </p:txBody>
-      </p:sp>
-      <p:sp>
-        <p:nvSpPr>
-          <p:cNvPr id="4" name="TextBox 3"/>
-          <p:cNvSpPr txBox="1"/>
-          <p:nvPr/>
-        </p:nvSpPr>
-        <p:spPr>
-          <a:xfrm>
-            <a:off x="457200" y="1554480"/>
-            <a:ext cx="11247120" cy="4754880"/>
-          </a:xfrm>
-          <a:prstGeom prst="rect">
-            <a:avLst/>
-          </a:prstGeom>
-          <a:noFill/>
-        </p:spPr>
-        <p:txBody>
-          <a:bodyPr wrap="square">
-            <a:spAutoFit/>
-          </a:bodyPr>
-          <a:lstStyle/>
+              <a:t>Prototype-planning scaffold</a:t>
+            </a:r>
+          </a:p>
           <a:p>
             <a:pPr>
-              <a:spcAft>
-                <a:spcPts val="800"/>
-              </a:spcAft>
-              <a:defRPr sz="2200">
-                <a:solidFill>
-                  <a:srgbClr val="111111"/>
-                </a:solidFill>
-              </a:defRPr>
+              <a:defRPr sz="2000"/>
             </a:pPr>
             <a:r>
-              <a:t>Musical instrument documentation capstone</a:t>
+              <a:t>Compact 10-string plucked lyre</a:t>
             </a:r>
           </a:p>
           <a:p>
             <a:pPr>
-              <a:spcAft>
-                <a:spcPts val="800"/>
-              </a:spcAft>
-              <a:defRPr sz="2200">
-                <a:solidFill>
-                  <a:srgbClr val="111111"/>
-                </a:solidFill>
-              </a:defRPr>
+              <a:defRPr sz="2000"/>
             </a:pPr>
             <a:r>
-              <a:t>Build packet: lyre-codex-gina-r2-build-packet</a:t>
-            </a:r>
-          </a:p>
-          <a:p>
-            <a:pPr>
-              <a:spcAft>
-                <a:spcPts val="800"/>
-              </a:spcAft>
-              <a:defRPr sz="2200">
-                <a:solidFill>
-                  <a:srgbClr val="111111"/>
-                </a:solidFill>
-              </a:defRPr>
-            </a:pPr>
-            <a:r>
-              <a:t>Generated: 2026-05-09</a:t>
-            </a:r>
-          </a:p>
-        </p:txBody>
-      </p:sp>
-      <p:sp>
-        <p:nvSpPr>
-          <p:cNvPr id="5" name="TextBox 4"/>
-          <p:cNvSpPr txBox="1"/>
-          <p:nvPr/>
-        </p:nvSpPr>
-        <p:spPr>
-          <a:xfrm>
-            <a:off x="457200" y="6446520"/>
-            <a:ext cx="11247120" cy="274320"/>
-          </a:xfrm>
-          <a:prstGeom prst="rect">
-            <a:avLst/>
-          </a:prstGeom>
-          <a:noFill/>
-        </p:spPr>
-        <p:txBody>
-          <a:bodyPr wrap="none">
-            <a:spAutoFit/>
-          </a:bodyPr>
-          <a:lstStyle/>
-          <a:p>
-            <a:pPr>
-              <a:defRPr sz="1000">
-                <a:solidFill>
-                  <a:srgbClr val="445577"/>
-                </a:solidFill>
-              </a:defRPr>
-            </a:pPr>
-            <a:r>
-              <a:t>Lyre Build Packet  |  Slide 1 of 13</a:t>
-            </a:r>
-          </a:p>
-        </p:txBody>
-      </p:sp>
-    </p:spTree>
-  </p:cSld>
-  <p:clrMapOvr>
-    <a:masterClrMapping/>
-  </p:clrMapOvr>
-</p:sld>
-</file>
-
-<file path=ppt/slides/slide10.xml><?xml version="1.0" encoding="utf-8"?>
-<p:sld xmlns:a="http://schemas.openxmlformats.org/drawingml/2006/main" xmlns:p="http://schemas.openxmlformats.org/presentationml/2006/main" xmlns:r="http://schemas.openxmlformats.org/officeDocument/2006/relationships">
-  <p:cSld>
-    <p:spTree>
-      <p:nvGrpSpPr>
-        <p:cNvPr id="1" name=""/>
-        <p:cNvGrpSpPr/>
-        <p:nvPr/>
-      </p:nvGrpSpPr>
-      <p:grpSpPr/>
-      <p:sp>
-        <p:nvSpPr>
-          <p:cNvPr id="2" name="Rectangle 1"/>
-          <p:cNvSpPr/>
-          <p:nvPr/>
-        </p:nvSpPr>
-        <p:spPr>
-          <a:xfrm>
-            <a:off x="0" y="0"/>
-            <a:ext cx="12191695" cy="411480"/>
-          </a:xfrm>
-          <a:prstGeom prst="rect">
-            <a:avLst/>
-          </a:prstGeom>
-          <a:solidFill>
-            <a:srgbClr val="1F3A68"/>
-          </a:solidFill>
-          <a:ln>
-            <a:noFill/>
-          </a:ln>
-        </p:spPr>
-        <p:style>
-          <a:lnRef idx="1">
-            <a:schemeClr val="accent1"/>
-          </a:lnRef>
-          <a:fillRef idx="3">
-            <a:schemeClr val="accent1"/>
-          </a:fillRef>
-          <a:effectRef idx="2">
-            <a:schemeClr val="accent1"/>
-          </a:effectRef>
-          <a:fontRef idx="minor">
-            <a:schemeClr val="lt1"/>
-          </a:fontRef>
-        </p:style>
-        <p:txBody>
-          <a:bodyPr rtlCol="0" anchor="ctr"/>
-          <a:lstStyle/>
-          <a:p>
-            <a:pPr algn="ctr"/>
-          </a:p>
-        </p:txBody>
-      </p:sp>
-      <p:sp>
-        <p:nvSpPr>
-          <p:cNvPr id="3" name="TextBox 2"/>
-          <p:cNvSpPr txBox="1"/>
-          <p:nvPr/>
-        </p:nvSpPr>
-        <p:spPr>
-          <a:xfrm>
-            <a:off x="457200" y="548640"/>
-            <a:ext cx="11247120" cy="914400"/>
-          </a:xfrm>
-          <a:prstGeom prst="rect">
-            <a:avLst/>
-          </a:prstGeom>
-          <a:noFill/>
-        </p:spPr>
-        <p:txBody>
-          <a:bodyPr wrap="square">
-            <a:spAutoFit/>
-          </a:bodyPr>
-          <a:lstStyle/>
-          <a:p>
-            <a:pPr>
-              <a:defRPr sz="3000" b="1">
-                <a:solidFill>
-                  <a:srgbClr val="1F3A68"/>
-                </a:solidFill>
-              </a:defRPr>
-            </a:pPr>
-            <a:r>
-              <a:t>Images And Screenshots</a:t>
-            </a:r>
-          </a:p>
-        </p:txBody>
-      </p:sp>
-      <p:sp>
-        <p:nvSpPr>
-          <p:cNvPr id="4" name="TextBox 3"/>
-          <p:cNvSpPr txBox="1"/>
-          <p:nvPr/>
-        </p:nvSpPr>
-        <p:spPr>
-          <a:xfrm>
-            <a:off x="457200" y="1463040"/>
-            <a:ext cx="5943600" cy="4754880"/>
-          </a:xfrm>
-          <a:prstGeom prst="rect">
-            <a:avLst/>
-          </a:prstGeom>
-          <a:noFill/>
-        </p:spPr>
-        <p:txBody>
-          <a:bodyPr wrap="square">
-            <a:spAutoFit/>
-          </a:bodyPr>
-          <a:lstStyle/>
-          <a:p>
-            <a:pPr>
-              <a:spcAft>
-                <a:spcPts val="800"/>
-              </a:spcAft>
-              <a:defRPr sz="2000">
-                <a:solidFill>
-                  <a:srgbClr val="445577"/>
-                </a:solidFill>
-              </a:defRPr>
-            </a:pPr>
-            <a:r>
-              <a:t>• images/P-Lyre-Harp-1200x1200-1_1080xinspiration.webp</a:t>
-            </a:r>
-          </a:p>
-        </p:txBody>
-      </p:sp>
-      <p:sp>
-        <p:nvSpPr>
-          <p:cNvPr id="5" name="TextBox 4"/>
-          <p:cNvSpPr txBox="1"/>
-          <p:nvPr/>
-        </p:nvSpPr>
-        <p:spPr>
-          <a:xfrm>
-            <a:off x="457200" y="6446520"/>
-            <a:ext cx="11247120" cy="274320"/>
-          </a:xfrm>
-          <a:prstGeom prst="rect">
-            <a:avLst/>
-          </a:prstGeom>
-          <a:noFill/>
-        </p:spPr>
-        <p:txBody>
-          <a:bodyPr wrap="none">
-            <a:spAutoFit/>
-          </a:bodyPr>
-          <a:lstStyle/>
-          <a:p>
-            <a:pPr>
-              <a:defRPr sz="1000">
-                <a:solidFill>
-                  <a:srgbClr val="445577"/>
-                </a:solidFill>
-              </a:defRPr>
-            </a:pPr>
-            <a:r>
-              <a:t>Lyre Build Packet  |  Slide 10 of 13</a:t>
-            </a:r>
-          </a:p>
-        </p:txBody>
-      </p:sp>
-    </p:spTree>
-  </p:cSld>
-  <p:clrMapOvr>
-    <a:masterClrMapping/>
-  </p:clrMapOvr>
-</p:sld>
-</file>
-
-<file path=ppt/slides/slide11.xml><?xml version="1.0" encoding="utf-8"?>
-<p:sld xmlns:a="http://schemas.openxmlformats.org/drawingml/2006/main" xmlns:p="http://schemas.openxmlformats.org/presentationml/2006/main" xmlns:r="http://schemas.openxmlformats.org/officeDocument/2006/relationships">
-  <p:cSld>
-    <p:spTree>
-      <p:nvGrpSpPr>
-        <p:cNvPr id="1" name=""/>
-        <p:cNvGrpSpPr/>
-        <p:nvPr/>
-      </p:nvGrpSpPr>
-      <p:grpSpPr/>
-      <p:sp>
-        <p:nvSpPr>
-          <p:cNvPr id="2" name="Rectangle 1"/>
-          <p:cNvSpPr/>
-          <p:nvPr/>
-        </p:nvSpPr>
-        <p:spPr>
-          <a:xfrm>
-            <a:off x="0" y="0"/>
-            <a:ext cx="12191695" cy="411480"/>
-          </a:xfrm>
-          <a:prstGeom prst="rect">
-            <a:avLst/>
-          </a:prstGeom>
-          <a:solidFill>
-            <a:srgbClr val="1F3A68"/>
-          </a:solidFill>
-          <a:ln>
-            <a:noFill/>
-          </a:ln>
-        </p:spPr>
-        <p:style>
-          <a:lnRef idx="1">
-            <a:schemeClr val="accent1"/>
-          </a:lnRef>
-          <a:fillRef idx="3">
-            <a:schemeClr val="accent1"/>
-          </a:fillRef>
-          <a:effectRef idx="2">
-            <a:schemeClr val="accent1"/>
-          </a:effectRef>
-          <a:fontRef idx="minor">
-            <a:schemeClr val="lt1"/>
-          </a:fontRef>
-        </p:style>
-        <p:txBody>
-          <a:bodyPr rtlCol="0" anchor="ctr"/>
-          <a:lstStyle/>
-          <a:p>
-            <a:pPr algn="ctr"/>
-          </a:p>
-        </p:txBody>
-      </p:sp>
-      <p:sp>
-        <p:nvSpPr>
-          <p:cNvPr id="3" name="TextBox 2"/>
-          <p:cNvSpPr txBox="1"/>
-          <p:nvPr/>
-        </p:nvSpPr>
-        <p:spPr>
-          <a:xfrm>
-            <a:off x="457200" y="548640"/>
-            <a:ext cx="11247120" cy="914400"/>
-          </a:xfrm>
-          <a:prstGeom prst="rect">
-            <a:avLst/>
-          </a:prstGeom>
-          <a:noFill/>
-        </p:spPr>
-        <p:txBody>
-          <a:bodyPr wrap="square">
-            <a:spAutoFit/>
-          </a:bodyPr>
-          <a:lstStyle/>
-          <a:p>
-            <a:pPr>
-              <a:defRPr sz="3000" b="1">
-                <a:solidFill>
-                  <a:srgbClr val="1F3A68"/>
-                </a:solidFill>
-              </a:defRPr>
-            </a:pPr>
-            <a:r>
-              <a:t>Validation Plan</a:t>
-            </a:r>
-          </a:p>
-        </p:txBody>
-      </p:sp>
-      <p:sp>
-        <p:nvSpPr>
-          <p:cNvPr id="4" name="TextBox 3"/>
-          <p:cNvSpPr txBox="1"/>
-          <p:nvPr/>
-        </p:nvSpPr>
-        <p:spPr>
-          <a:xfrm>
-            <a:off x="457200" y="1463040"/>
-            <a:ext cx="11247120" cy="4754880"/>
-          </a:xfrm>
-          <a:prstGeom prst="rect">
-            <a:avLst/>
-          </a:prstGeom>
-          <a:noFill/>
-        </p:spPr>
-        <p:txBody>
-          <a:bodyPr wrap="square">
-            <a:spAutoFit/>
-          </a:bodyPr>
-          <a:lstStyle/>
-          <a:p>
-            <a:pPr>
-              <a:spcAft>
-                <a:spcPts val="800"/>
-              </a:spcAft>
-              <a:defRPr sz="2000">
-                <a:solidFill>
-                  <a:srgbClr val="445577"/>
-                </a:solidFill>
-              </a:defRPr>
-            </a:pPr>
-            <a:r>
-              <a:t>• A4 = 440 Hz reference check.</a:t>
-            </a:r>
-          </a:p>
-          <a:p>
-            <a:pPr>
-              <a:spcAft>
-                <a:spcPts val="800"/>
-              </a:spcAft>
-              <a:defRPr sz="2000">
-                <a:solidFill>
-                  <a:srgbClr val="445577"/>
-                </a:solidFill>
-              </a:defRPr>
-            </a:pPr>
-            <a:r>
-              <a:t>• Tuning targets logged in validation.csv.</a:t>
-            </a:r>
-          </a:p>
-          <a:p>
-            <a:pPr>
-              <a:spcAft>
-                <a:spcPts val="800"/>
-              </a:spcAft>
-              <a:defRPr sz="2000">
-                <a:solidFill>
-                  <a:srgbClr val="445577"/>
-                </a:solidFill>
-              </a:defRPr>
-            </a:pPr>
-            <a:r>
-              <a:t>• Critical dimensions verified against design sheet and CAD.</a:t>
-            </a:r>
-          </a:p>
-          <a:p>
-            <a:pPr>
-              <a:spcAft>
-                <a:spcPts val="800"/>
-              </a:spcAft>
-              <a:defRPr sz="2000">
-                <a:solidFill>
-                  <a:srgbClr val="445577"/>
-                </a:solidFill>
-              </a:defRPr>
-            </a:pPr>
-            <a:r>
-              <a:t>• Photos and revision notes after each major step.</a:t>
-            </a:r>
-          </a:p>
-        </p:txBody>
-      </p:sp>
-      <p:sp>
-        <p:nvSpPr>
-          <p:cNvPr id="5" name="TextBox 4"/>
-          <p:cNvSpPr txBox="1"/>
-          <p:nvPr/>
-        </p:nvSpPr>
-        <p:spPr>
-          <a:xfrm>
-            <a:off x="457200" y="6446520"/>
-            <a:ext cx="11247120" cy="274320"/>
-          </a:xfrm>
-          <a:prstGeom prst="rect">
-            <a:avLst/>
-          </a:prstGeom>
-          <a:noFill/>
-        </p:spPr>
-        <p:txBody>
-          <a:bodyPr wrap="none">
-            <a:spAutoFit/>
-          </a:bodyPr>
-          <a:lstStyle/>
-          <a:p>
-            <a:pPr>
-              <a:defRPr sz="1000">
-                <a:solidFill>
-                  <a:srgbClr val="445577"/>
-                </a:solidFill>
-              </a:defRPr>
-            </a:pPr>
-            <a:r>
-              <a:t>Lyre Build Packet  |  Slide 11 of 13</a:t>
-            </a:r>
-          </a:p>
-        </p:txBody>
-      </p:sp>
-    </p:spTree>
-  </p:cSld>
-  <p:clrMapOvr>
-    <a:masterClrMapping/>
-  </p:clrMapOvr>
-</p:sld>
-</file>
-
-<file path=ppt/slides/slide12.xml><?xml version="1.0" encoding="utf-8"?>
-<p:sld xmlns:a="http://schemas.openxmlformats.org/drawingml/2006/main" xmlns:p="http://schemas.openxmlformats.org/presentationml/2006/main" xmlns:r="http://schemas.openxmlformats.org/officeDocument/2006/relationships">
-  <p:cSld>
-    <p:spTree>
-      <p:nvGrpSpPr>
-        <p:cNvPr id="1" name=""/>
-        <p:cNvGrpSpPr/>
-        <p:nvPr/>
-      </p:nvGrpSpPr>
-      <p:grpSpPr/>
-      <p:sp>
-        <p:nvSpPr>
-          <p:cNvPr id="2" name="Rectangle 1"/>
-          <p:cNvSpPr/>
-          <p:nvPr/>
-        </p:nvSpPr>
-        <p:spPr>
-          <a:xfrm>
-            <a:off x="0" y="0"/>
-            <a:ext cx="12191695" cy="411480"/>
-          </a:xfrm>
-          <a:prstGeom prst="rect">
-            <a:avLst/>
-          </a:prstGeom>
-          <a:solidFill>
-            <a:srgbClr val="1F3A68"/>
-          </a:solidFill>
-          <a:ln>
-            <a:noFill/>
-          </a:ln>
-        </p:spPr>
-        <p:style>
-          <a:lnRef idx="1">
-            <a:schemeClr val="accent1"/>
-          </a:lnRef>
-          <a:fillRef idx="3">
-            <a:schemeClr val="accent1"/>
-          </a:fillRef>
-          <a:effectRef idx="2">
-            <a:schemeClr val="accent1"/>
-          </a:effectRef>
-          <a:fontRef idx="minor">
-            <a:schemeClr val="lt1"/>
-          </a:fontRef>
-        </p:style>
-        <p:txBody>
-          <a:bodyPr rtlCol="0" anchor="ctr"/>
-          <a:lstStyle/>
-          <a:p>
-            <a:pPr algn="ctr"/>
-          </a:p>
-        </p:txBody>
-      </p:sp>
-      <p:sp>
-        <p:nvSpPr>
-          <p:cNvPr id="3" name="TextBox 2"/>
-          <p:cNvSpPr txBox="1"/>
-          <p:nvPr/>
-        </p:nvSpPr>
-        <p:spPr>
-          <a:xfrm>
-            <a:off x="457200" y="548640"/>
-            <a:ext cx="11247120" cy="914400"/>
-          </a:xfrm>
-          <a:prstGeom prst="rect">
-            <a:avLst/>
-          </a:prstGeom>
-          <a:noFill/>
-        </p:spPr>
-        <p:txBody>
-          <a:bodyPr wrap="square">
-            <a:spAutoFit/>
-          </a:bodyPr>
-          <a:lstStyle/>
-          <a:p>
-            <a:pPr>
-              <a:defRPr sz="3000" b="1">
-                <a:solidFill>
-                  <a:srgbClr val="1F3A68"/>
-                </a:solidFill>
-              </a:defRPr>
-            </a:pPr>
-            <a:r>
-              <a:t>Open Risks / Decisions</a:t>
-            </a:r>
-          </a:p>
-        </p:txBody>
-      </p:sp>
-      <p:sp>
-        <p:nvSpPr>
-          <p:cNvPr id="4" name="TextBox 3"/>
-          <p:cNvSpPr txBox="1"/>
-          <p:nvPr/>
-        </p:nvSpPr>
-        <p:spPr>
-          <a:xfrm>
-            <a:off x="457200" y="1463040"/>
-            <a:ext cx="11247120" cy="4754880"/>
-          </a:xfrm>
-          <a:prstGeom prst="rect">
-            <a:avLst/>
-          </a:prstGeom>
-          <a:noFill/>
-        </p:spPr>
-        <p:txBody>
-          <a:bodyPr wrap="square">
-            <a:spAutoFit/>
-          </a:bodyPr>
-          <a:lstStyle/>
-          <a:p>
-            <a:pPr>
-              <a:spcAft>
-                <a:spcPts val="800"/>
-              </a:spcAft>
-              <a:defRPr sz="2000">
-                <a:solidFill>
-                  <a:srgbClr val="445577"/>
-                </a:solidFill>
-              </a:defRPr>
-            </a:pPr>
-            <a:r>
-              <a:t>• TBDs in design sheet and BOM.</a:t>
-            </a:r>
-          </a:p>
-          <a:p>
-            <a:pPr>
-              <a:spcAft>
-                <a:spcPts val="800"/>
-              </a:spcAft>
-              <a:defRPr sz="2000">
-                <a:solidFill>
-                  <a:srgbClr val="445577"/>
-                </a:solidFill>
-              </a:defRPr>
-            </a:pPr>
-            <a:r>
-              <a:t>• Supplier price/availability not yet verified.</a:t>
-            </a:r>
-          </a:p>
-          <a:p>
-            <a:pPr>
-              <a:spcAft>
-                <a:spcPts val="800"/>
-              </a:spcAft>
-              <a:defRPr sz="2000">
-                <a:solidFill>
-                  <a:srgbClr val="445577"/>
-                </a:solidFill>
-              </a:defRPr>
-            </a:pPr>
-            <a:r>
-              <a:t>• Generated images marked as concept placeholders.</a:t>
-            </a:r>
-          </a:p>
-          <a:p>
-            <a:pPr>
-              <a:spcAft>
-                <a:spcPts val="800"/>
-              </a:spcAft>
-              <a:defRPr sz="2000">
-                <a:solidFill>
-                  <a:srgbClr val="445577"/>
-                </a:solidFill>
-              </a:defRPr>
-            </a:pPr>
-            <a:r>
-              <a:t>• Empirical corrections await measured prototype data.</a:t>
-            </a:r>
-          </a:p>
-        </p:txBody>
-      </p:sp>
-      <p:sp>
-        <p:nvSpPr>
-          <p:cNvPr id="5" name="TextBox 4"/>
-          <p:cNvSpPr txBox="1"/>
-          <p:nvPr/>
-        </p:nvSpPr>
-        <p:spPr>
-          <a:xfrm>
-            <a:off x="457200" y="6446520"/>
-            <a:ext cx="11247120" cy="274320"/>
-          </a:xfrm>
-          <a:prstGeom prst="rect">
-            <a:avLst/>
-          </a:prstGeom>
-          <a:noFill/>
-        </p:spPr>
-        <p:txBody>
-          <a:bodyPr wrap="none">
-            <a:spAutoFit/>
-          </a:bodyPr>
-          <a:lstStyle/>
-          <a:p>
-            <a:pPr>
-              <a:defRPr sz="1000">
-                <a:solidFill>
-                  <a:srgbClr val="445577"/>
-                </a:solidFill>
-              </a:defRPr>
-            </a:pPr>
-            <a:r>
-              <a:t>Lyre Build Packet  |  Slide 12 of 13</a:t>
-            </a:r>
-          </a:p>
-        </p:txBody>
-      </p:sp>
-    </p:spTree>
-  </p:cSld>
-  <p:clrMapOvr>
-    <a:masterClrMapping/>
-  </p:clrMapOvr>
-</p:sld>
-</file>
-
-<file path=ppt/slides/slide13.xml><?xml version="1.0" encoding="utf-8"?>
-<p:sld xmlns:a="http://schemas.openxmlformats.org/drawingml/2006/main" xmlns:p="http://schemas.openxmlformats.org/presentationml/2006/main" xmlns:r="http://schemas.openxmlformats.org/officeDocument/2006/relationships">
-  <p:cSld>
-    <p:spTree>
-      <p:nvGrpSpPr>
-        <p:cNvPr id="1" name=""/>
-        <p:cNvGrpSpPr/>
-        <p:nvPr/>
-      </p:nvGrpSpPr>
-      <p:grpSpPr/>
-      <p:sp>
-        <p:nvSpPr>
-          <p:cNvPr id="2" name="Rectangle 1"/>
-          <p:cNvSpPr/>
-          <p:nvPr/>
-        </p:nvSpPr>
-        <p:spPr>
-          <a:xfrm>
-            <a:off x="0" y="0"/>
-            <a:ext cx="12191695" cy="411480"/>
-          </a:xfrm>
-          <a:prstGeom prst="rect">
-            <a:avLst/>
-          </a:prstGeom>
-          <a:solidFill>
-            <a:srgbClr val="1F3A68"/>
-          </a:solidFill>
-          <a:ln>
-            <a:noFill/>
-          </a:ln>
-        </p:spPr>
-        <p:style>
-          <a:lnRef idx="1">
-            <a:schemeClr val="accent1"/>
-          </a:lnRef>
-          <a:fillRef idx="3">
-            <a:schemeClr val="accent1"/>
-          </a:fillRef>
-          <a:effectRef idx="2">
-            <a:schemeClr val="accent1"/>
-          </a:effectRef>
-          <a:fontRef idx="minor">
-            <a:schemeClr val="lt1"/>
-          </a:fontRef>
-        </p:style>
-        <p:txBody>
-          <a:bodyPr rtlCol="0" anchor="ctr"/>
-          <a:lstStyle/>
-          <a:p>
-            <a:pPr algn="ctr"/>
-          </a:p>
-        </p:txBody>
-      </p:sp>
-      <p:sp>
-        <p:nvSpPr>
-          <p:cNvPr id="3" name="TextBox 2"/>
-          <p:cNvSpPr txBox="1"/>
-          <p:nvPr/>
-        </p:nvSpPr>
-        <p:spPr>
-          <a:xfrm>
-            <a:off x="457200" y="548640"/>
-            <a:ext cx="11247120" cy="914400"/>
-          </a:xfrm>
-          <a:prstGeom prst="rect">
-            <a:avLst/>
-          </a:prstGeom>
-          <a:noFill/>
-        </p:spPr>
-        <p:txBody>
-          <a:bodyPr wrap="square">
-            <a:spAutoFit/>
-          </a:bodyPr>
-          <a:lstStyle/>
-          <a:p>
-            <a:pPr>
-              <a:defRPr sz="3000" b="1">
-                <a:solidFill>
-                  <a:srgbClr val="1F3A68"/>
-                </a:solidFill>
-              </a:defRPr>
-            </a:pPr>
-            <a:r>
-              <a:t>Next Actions</a:t>
-            </a:r>
-          </a:p>
-        </p:txBody>
-      </p:sp>
-      <p:sp>
-        <p:nvSpPr>
-          <p:cNvPr id="4" name="TextBox 3"/>
-          <p:cNvSpPr txBox="1"/>
-          <p:nvPr/>
-        </p:nvSpPr>
-        <p:spPr>
-          <a:xfrm>
-            <a:off x="457200" y="1463040"/>
-            <a:ext cx="11247120" cy="4754880"/>
-          </a:xfrm>
-          <a:prstGeom prst="rect">
-            <a:avLst/>
-          </a:prstGeom>
-          <a:noFill/>
-        </p:spPr>
-        <p:txBody>
-          <a:bodyPr wrap="square">
-            <a:spAutoFit/>
-          </a:bodyPr>
-          <a:lstStyle/>
-          <a:p>
-            <a:pPr>
-              <a:spcAft>
-                <a:spcPts val="800"/>
-              </a:spcAft>
-              <a:defRPr sz="2000">
-                <a:solidFill>
-                  <a:srgbClr val="445577"/>
-                </a:solidFill>
-              </a:defRPr>
-            </a:pPr>
-            <a:r>
-              <a:t>• Replace TBDs with measured/source-backed values.</a:t>
-            </a:r>
-          </a:p>
-          <a:p>
-            <a:pPr>
-              <a:spcAft>
-                <a:spcPts val="800"/>
-              </a:spcAft>
-              <a:defRPr sz="2000">
-                <a:solidFill>
-                  <a:srgbClr val="445577"/>
-                </a:solidFill>
-              </a:defRPr>
-            </a:pPr>
-            <a:r>
-              <a:t>• Verify live supplier price and availability before buying.</a:t>
-            </a:r>
-          </a:p>
-          <a:p>
-            <a:pPr>
-              <a:spcAft>
-                <a:spcPts val="800"/>
-              </a:spcAft>
-              <a:defRPr sz="2000">
-                <a:solidFill>
-                  <a:srgbClr val="445577"/>
-                </a:solidFill>
-              </a:defRPr>
-            </a:pPr>
-            <a:r>
-              <a:t>• Export final drawings and visual BOM images.</a:t>
-            </a:r>
-          </a:p>
-          <a:p>
-            <a:pPr>
-              <a:spcAft>
-                <a:spcPts val="800"/>
-              </a:spcAft>
-              <a:defRPr sz="2000">
-                <a:solidFill>
-                  <a:srgbClr val="445577"/>
-                </a:solidFill>
-              </a:defRPr>
-            </a:pPr>
-            <a:r>
-              <a:t>• Regenerate this deck and print packet after final edits.</a:t>
-            </a:r>
-          </a:p>
-        </p:txBody>
-      </p:sp>
-      <p:sp>
-        <p:nvSpPr>
-          <p:cNvPr id="5" name="TextBox 4"/>
-          <p:cNvSpPr txBox="1"/>
-          <p:nvPr/>
-        </p:nvSpPr>
-        <p:spPr>
-          <a:xfrm>
-            <a:off x="457200" y="6446520"/>
-            <a:ext cx="11247120" cy="274320"/>
-          </a:xfrm>
-          <a:prstGeom prst="rect">
-            <a:avLst/>
-          </a:prstGeom>
-          <a:noFill/>
-        </p:spPr>
-        <p:txBody>
-          <a:bodyPr wrap="none">
-            <a:spAutoFit/>
-          </a:bodyPr>
-          <a:lstStyle/>
-          <a:p>
-            <a:pPr>
-              <a:defRPr sz="1000">
-                <a:solidFill>
-                  <a:srgbClr val="445577"/>
-                </a:solidFill>
-              </a:defRPr>
-            </a:pPr>
-            <a:r>
-              <a:t>Lyre Build Packet  |  Slide 13 of 13</a:t>
+              <a:t>No build-ready or measured claims yet</a:t>
             </a:r>
           </a:p>
         </p:txBody>
@@ -4112,163 +3173,61 @@
       <p:grpSpPr/>
       <p:sp>
         <p:nvSpPr>
-          <p:cNvPr id="2" name="Rectangle 1"/>
-          <p:cNvSpPr/>
-          <p:nvPr/>
-        </p:nvSpPr>
-        <p:spPr>
-          <a:xfrm>
-            <a:off x="0" y="0"/>
-            <a:ext cx="12191695" cy="411480"/>
-          </a:xfrm>
-          <a:prstGeom prst="rect">
-            <a:avLst/>
-          </a:prstGeom>
-          <a:solidFill>
-            <a:srgbClr val="1F3A68"/>
-          </a:solidFill>
-          <a:ln>
-            <a:noFill/>
-          </a:ln>
-        </p:spPr>
-        <p:style>
-          <a:lnRef idx="1">
-            <a:schemeClr val="accent1"/>
-          </a:lnRef>
-          <a:fillRef idx="3">
-            <a:schemeClr val="accent1"/>
-          </a:fillRef>
-          <a:effectRef idx="2">
-            <a:schemeClr val="accent1"/>
-          </a:effectRef>
-          <a:fontRef idx="minor">
-            <a:schemeClr val="lt1"/>
-          </a:fontRef>
-        </p:style>
-        <p:txBody>
-          <a:bodyPr rtlCol="0" anchor="ctr"/>
-          <a:lstStyle/>
-          <a:p>
-            <a:pPr algn="ctr"/>
-          </a:p>
-        </p:txBody>
-      </p:sp>
-      <p:sp>
-        <p:nvSpPr>
-          <p:cNvPr id="3" name="TextBox 2"/>
-          <p:cNvSpPr txBox="1"/>
-          <p:nvPr/>
-        </p:nvSpPr>
-        <p:spPr>
-          <a:xfrm>
-            <a:off x="457200" y="548640"/>
-            <a:ext cx="11247120" cy="914400"/>
-          </a:xfrm>
-          <a:prstGeom prst="rect">
-            <a:avLst/>
-          </a:prstGeom>
-          <a:noFill/>
-        </p:spPr>
-        <p:txBody>
-          <a:bodyPr wrap="square">
-            <a:spAutoFit/>
-          </a:bodyPr>
+          <p:cNvPr id="2" name="Title 1"/>
+          <p:cNvSpPr>
+            <a:spLocks noGrp="1"/>
+          </p:cNvSpPr>
+          <p:nvPr>
+            <p:ph type="title"/>
+          </p:nvPr>
+        </p:nvSpPr>
+        <p:spPr/>
+        <p:txBody>
+          <a:bodyPr/>
+          <a:lstStyle/>
+          <a:p>
+            <a:r>
+              <a:t>Readiness Boundary</a:t>
+            </a:r>
+          </a:p>
+        </p:txBody>
+      </p:sp>
+      <p:sp>
+        <p:nvSpPr>
+          <p:cNvPr id="3" name="Content Placeholder 2"/>
+          <p:cNvSpPr>
+            <a:spLocks noGrp="1"/>
+          </p:cNvSpPr>
+          <p:nvPr>
+            <p:ph idx="1"/>
+          </p:nvPr>
+        </p:nvSpPr>
+        <p:spPr/>
+        <p:txBody>
+          <a:bodyPr/>
           <a:lstStyle/>
           <a:p>
             <a:pPr>
-              <a:defRPr sz="3000" b="1">
-                <a:solidFill>
-                  <a:srgbClr val="1F3A68"/>
-                </a:solidFill>
-              </a:defRPr>
+              <a:defRPr sz="2000"/>
             </a:pPr>
             <a:r>
-              <a:t>Project Intent</a:t>
-            </a:r>
-          </a:p>
-        </p:txBody>
-      </p:sp>
-      <p:sp>
-        <p:nvSpPr>
-          <p:cNvPr id="4" name="TextBox 3"/>
-          <p:cNvSpPr txBox="1"/>
-          <p:nvPr/>
-        </p:nvSpPr>
-        <p:spPr>
-          <a:xfrm>
-            <a:off x="457200" y="1463040"/>
-            <a:ext cx="11247120" cy="4754880"/>
-          </a:xfrm>
-          <a:prstGeom prst="rect">
-            <a:avLst/>
-          </a:prstGeom>
-          <a:noFill/>
-        </p:spPr>
-        <p:txBody>
-          <a:bodyPr wrap="square">
-            <a:spAutoFit/>
-          </a:bodyPr>
-          <a:lstStyle/>
+              <a:t>String gauges, tension, percent breaking, and load path remain measurement-required</a:t>
+            </a:r>
+          </a:p>
           <a:p>
             <a:pPr>
-              <a:spcAft>
-                <a:spcPts val="800"/>
-              </a:spcAft>
-              <a:defRPr sz="2000">
-                <a:solidFill>
-                  <a:srgbClr val="445577"/>
-                </a:solidFill>
-              </a:defRPr>
+              <a:defRPr sz="2000"/>
             </a:pPr>
             <a:r>
-              <a:t>• Create a small bench-buildable lyre packet that can move from concept to a</a:t>
-            </a:r>
-            <a:br/>
-            <a:r>
-              <a:t>first shop prototype without hiding the important string-load unknowns. The</a:t>
-            </a:r>
-            <a:br/>
-            <a:r>
-              <a:t>baseline is a compact 10-string plucked instrument with a flat soundboard,</a:t>
-            </a:r>
-            <a:br/>
-            <a:r>
-              <a:t>two arms, a crossbar/yoke, and individual tuning pins.</a:t>
-            </a:r>
-          </a:p>
-        </p:txBody>
-      </p:sp>
-      <p:sp>
-        <p:nvSpPr>
-          <p:cNvPr id="5" name="TextBox 4"/>
-          <p:cNvSpPr txBox="1"/>
-          <p:nvPr/>
-        </p:nvSpPr>
-        <p:spPr>
-          <a:xfrm>
-            <a:off x="457200" y="6446520"/>
-            <a:ext cx="11247120" cy="274320"/>
-          </a:xfrm>
-          <a:prstGeom prst="rect">
-            <a:avLst/>
-          </a:prstGeom>
-          <a:noFill/>
-        </p:spPr>
-        <p:txBody>
-          <a:bodyPr wrap="none">
-            <a:spAutoFit/>
-          </a:bodyPr>
-          <a:lstStyle/>
+              <a:t>CAD/drawings are starter notes only</a:t>
+            </a:r>
+          </a:p>
           <a:p>
             <a:pPr>
-              <a:defRPr sz="1000">
-                <a:solidFill>
-                  <a:srgbClr val="445577"/>
-                </a:solidFill>
-              </a:defRPr>
+              <a:defRPr sz="2000"/>
             </a:pPr>
             <a:r>
-              <a:t>Lyre Build Packet  |  Slide 2 of 13</a:t>
+              <a:t>Visual outputs are reference/review surfaces, not fabrication authority</a:t>
             </a:r>
           </a:p>
         </p:txBody>
@@ -4293,171 +3252,61 @@
       <p:grpSpPr/>
       <p:sp>
         <p:nvSpPr>
-          <p:cNvPr id="2" name="Rectangle 1"/>
-          <p:cNvSpPr/>
-          <p:nvPr/>
-        </p:nvSpPr>
-        <p:spPr>
-          <a:xfrm>
-            <a:off x="0" y="0"/>
-            <a:ext cx="12191695" cy="411480"/>
-          </a:xfrm>
-          <a:prstGeom prst="rect">
-            <a:avLst/>
-          </a:prstGeom>
-          <a:solidFill>
-            <a:srgbClr val="1F3A68"/>
-          </a:solidFill>
-          <a:ln>
-            <a:noFill/>
-          </a:ln>
-        </p:spPr>
-        <p:style>
-          <a:lnRef idx="1">
-            <a:schemeClr val="accent1"/>
-          </a:lnRef>
-          <a:fillRef idx="3">
-            <a:schemeClr val="accent1"/>
-          </a:fillRef>
-          <a:effectRef idx="2">
-            <a:schemeClr val="accent1"/>
-          </a:effectRef>
-          <a:fontRef idx="minor">
-            <a:schemeClr val="lt1"/>
-          </a:fontRef>
-        </p:style>
-        <p:txBody>
-          <a:bodyPr rtlCol="0" anchor="ctr"/>
-          <a:lstStyle/>
-          <a:p>
-            <a:pPr algn="ctr"/>
-          </a:p>
-        </p:txBody>
-      </p:sp>
-      <p:sp>
-        <p:nvSpPr>
-          <p:cNvPr id="3" name="TextBox 2"/>
-          <p:cNvSpPr txBox="1"/>
-          <p:nvPr/>
-        </p:nvSpPr>
-        <p:spPr>
-          <a:xfrm>
-            <a:off x="457200" y="548640"/>
-            <a:ext cx="11247120" cy="914400"/>
-          </a:xfrm>
-          <a:prstGeom prst="rect">
-            <a:avLst/>
-          </a:prstGeom>
-          <a:noFill/>
-        </p:spPr>
-        <p:txBody>
-          <a:bodyPr wrap="square">
-            <a:spAutoFit/>
-          </a:bodyPr>
+          <p:cNvPr id="2" name="Title 1"/>
+          <p:cNvSpPr>
+            <a:spLocks noGrp="1"/>
+          </p:cNvSpPr>
+          <p:nvPr>
+            <p:ph type="title"/>
+          </p:nvPr>
+        </p:nvSpPr>
+        <p:spPr/>
+        <p:txBody>
+          <a:bodyPr/>
+          <a:lstStyle/>
+          <a:p>
+            <a:r>
+              <a:t>New Evidence Gates</a:t>
+            </a:r>
+          </a:p>
+        </p:txBody>
+      </p:sp>
+      <p:sp>
+        <p:nvSpPr>
+          <p:cNvPr id="3" name="Content Placeholder 2"/>
+          <p:cNvSpPr>
+            <a:spLocks noGrp="1"/>
+          </p:cNvSpPr>
+          <p:nvPr>
+            <p:ph idx="1"/>
+          </p:nvPr>
+        </p:nvSpPr>
+        <p:spPr/>
+        <p:txBody>
+          <a:bodyPr/>
           <a:lstStyle/>
           <a:p>
             <a:pPr>
-              <a:defRPr sz="3000" b="1">
-                <a:solidFill>
-                  <a:srgbClr val="1F3A68"/>
-                </a:solidFill>
-              </a:defRPr>
+              <a:defRPr sz="2000"/>
             </a:pPr>
             <a:r>
-              <a:t>Physics Model</a:t>
-            </a:r>
-          </a:p>
-        </p:txBody>
-      </p:sp>
-      <p:sp>
-        <p:nvSpPr>
-          <p:cNvPr id="4" name="TextBox 3"/>
-          <p:cNvSpPr txBox="1"/>
-          <p:nvPr/>
-        </p:nvSpPr>
-        <p:spPr>
-          <a:xfrm>
-            <a:off x="457200" y="1463040"/>
-            <a:ext cx="11247120" cy="4754880"/>
-          </a:xfrm>
-          <a:prstGeom prst="rect">
-            <a:avLst/>
-          </a:prstGeom>
-          <a:noFill/>
-        </p:spPr>
-        <p:txBody>
-          <a:bodyPr wrap="square">
-            <a:spAutoFit/>
-          </a:bodyPr>
-          <a:lstStyle/>
+              <a:t>string-schedule.csv for C4-E5 targets and unresolved tension fields</a:t>
+            </a:r>
+          </a:p>
           <a:p>
             <a:pPr>
-              <a:spcAft>
-                <a:spcPts val="800"/>
-              </a:spcAft>
-              <a:defRPr sz="2000">
-                <a:solidFill>
-                  <a:srgbClr val="445577"/>
-                </a:solidFill>
-              </a:defRPr>
+              <a:defRPr sz="2000"/>
             </a:pPr>
             <a:r>
-              <a:t>• Strings use the Mersenne-Taylor relationship:</a:t>
+              <a:t>bridge-soundboard-load-register.csv for bridge, soundboard, yoke, pins, and joinery</a:t>
             </a:r>
           </a:p>
           <a:p>
             <a:pPr>
-              <a:spcAft>
-                <a:spcPts val="1000"/>
-              </a:spcAft>
-              <a:defRPr sz="1600">
-                <a:solidFill>
-                  <a:srgbClr val="1F3A68"/>
-                </a:solidFill>
-                <a:latin typeface="Consolas"/>
-              </a:defRPr>
+              <a:defRPr sz="2000"/>
             </a:pPr>
             <a:r>
-              <a:t>f = (1 / (2 L)) * sqrt(T / mu)</a:t>
-            </a:r>
-            <a:br/>
-            <a:r>
-              <a:t>mu = density * pi * (diameter / 2)^2</a:t>
-            </a:r>
-          </a:p>
-        </p:txBody>
-      </p:sp>
-      <p:sp>
-        <p:nvSpPr>
-          <p:cNvPr id="5" name="TextBox 4"/>
-          <p:cNvSpPr txBox="1"/>
-          <p:nvPr/>
-        </p:nvSpPr>
-        <p:spPr>
-          <a:xfrm>
-            <a:off x="457200" y="6446520"/>
-            <a:ext cx="11247120" cy="274320"/>
-          </a:xfrm>
-          <a:prstGeom prst="rect">
-            <a:avLst/>
-          </a:prstGeom>
-          <a:noFill/>
-        </p:spPr>
-        <p:txBody>
-          <a:bodyPr wrap="none">
-            <a:spAutoFit/>
-          </a:bodyPr>
-          <a:lstStyle/>
-          <a:p>
-            <a:pPr>
-              <a:defRPr sz="1000">
-                <a:solidFill>
-                  <a:srgbClr val="445577"/>
-                </a:solidFill>
-              </a:defRPr>
-            </a:pPr>
-            <a:r>
-              <a:t>Lyre Build Packet  |  Slide 3 of 13</a:t>
+              <a:t>visual-output-register.csv for non-authoritative images and exports</a:t>
             </a:r>
           </a:p>
         </p:txBody>
@@ -4482,196 +3331,69 @@
       <p:grpSpPr/>
       <p:sp>
         <p:nvSpPr>
-          <p:cNvPr id="2" name="Rectangle 1"/>
-          <p:cNvSpPr/>
-          <p:nvPr/>
-        </p:nvSpPr>
-        <p:spPr>
-          <a:xfrm>
-            <a:off x="0" y="0"/>
-            <a:ext cx="12191695" cy="411480"/>
-          </a:xfrm>
-          <a:prstGeom prst="rect">
-            <a:avLst/>
-          </a:prstGeom>
-          <a:solidFill>
-            <a:srgbClr val="1F3A68"/>
-          </a:solidFill>
-          <a:ln>
-            <a:noFill/>
-          </a:ln>
-        </p:spPr>
-        <p:style>
-          <a:lnRef idx="1">
-            <a:schemeClr val="accent1"/>
-          </a:lnRef>
-          <a:fillRef idx="3">
-            <a:schemeClr val="accent1"/>
-          </a:fillRef>
-          <a:effectRef idx="2">
-            <a:schemeClr val="accent1"/>
-          </a:effectRef>
-          <a:fontRef idx="minor">
-            <a:schemeClr val="lt1"/>
-          </a:fontRef>
-        </p:style>
-        <p:txBody>
-          <a:bodyPr rtlCol="0" anchor="ctr"/>
-          <a:lstStyle/>
-          <a:p>
-            <a:pPr algn="ctr"/>
-          </a:p>
-        </p:txBody>
-      </p:sp>
-      <p:sp>
-        <p:nvSpPr>
-          <p:cNvPr id="3" name="TextBox 2"/>
-          <p:cNvSpPr txBox="1"/>
-          <p:nvPr/>
-        </p:nvSpPr>
-        <p:spPr>
-          <a:xfrm>
-            <a:off x="457200" y="548640"/>
-            <a:ext cx="11247120" cy="914400"/>
-          </a:xfrm>
-          <a:prstGeom prst="rect">
-            <a:avLst/>
-          </a:prstGeom>
-          <a:noFill/>
-        </p:spPr>
-        <p:txBody>
-          <a:bodyPr wrap="square">
-            <a:spAutoFit/>
-          </a:bodyPr>
+          <p:cNvPr id="2" name="Title 1"/>
+          <p:cNvSpPr>
+            <a:spLocks noGrp="1"/>
+          </p:cNvSpPr>
+          <p:nvPr>
+            <p:ph type="title"/>
+          </p:nvPr>
+        </p:nvSpPr>
+        <p:spPr/>
+        <p:txBody>
+          <a:bodyPr/>
+          <a:lstStyle/>
+          <a:p>
+            <a:r>
+              <a:t>Validation</a:t>
+            </a:r>
+          </a:p>
+        </p:txBody>
+      </p:sp>
+      <p:sp>
+        <p:nvSpPr>
+          <p:cNvPr id="3" name="Content Placeholder 2"/>
+          <p:cNvSpPr>
+            <a:spLocks noGrp="1"/>
+          </p:cNvSpPr>
+          <p:nvPr>
+            <p:ph idx="1"/>
+          </p:nvPr>
+        </p:nvSpPr>
+        <p:spPr/>
+        <p:txBody>
+          <a:bodyPr/>
           <a:lstStyle/>
           <a:p>
             <a:pPr>
-              <a:defRPr sz="3000" b="1">
-                <a:solidFill>
-                  <a:srgbClr val="1F3A68"/>
-                </a:solidFill>
-              </a:defRPr>
+              <a:defRPr sz="2000"/>
             </a:pPr>
             <a:r>
-              <a:t>How To Use This Packet</a:t>
-            </a:r>
-          </a:p>
-        </p:txBody>
-      </p:sp>
-      <p:sp>
-        <p:nvSpPr>
-          <p:cNvPr id="4" name="TextBox 3"/>
-          <p:cNvSpPr txBox="1"/>
-          <p:nvPr/>
-        </p:nvSpPr>
-        <p:spPr>
-          <a:xfrm>
-            <a:off x="457200" y="1463040"/>
-            <a:ext cx="11247120" cy="4754880"/>
-          </a:xfrm>
-          <a:prstGeom prst="rect">
-            <a:avLst/>
-          </a:prstGeom>
-          <a:noFill/>
-        </p:spPr>
-        <p:txBody>
-          <a:bodyPr wrap="square">
-            <a:spAutoFit/>
-          </a:bodyPr>
-          <a:lstStyle/>
+              <a:t>Pitch-up after selected string schedule</a:t>
+            </a:r>
+          </a:p>
           <a:p>
             <a:pPr>
-              <a:spcAft>
-                <a:spcPts val="800"/>
-              </a:spcAft>
-              <a:defRPr sz="2000">
-                <a:solidFill>
-                  <a:srgbClr val="445577"/>
-                </a:solidFill>
-              </a:defRPr>
+              <a:defRPr sz="2000"/>
             </a:pPr>
             <a:r>
-              <a:t>• Start with design.md for intent and assumptions.</a:t>
+              <a:t>Scrap-block tuning pin torque and creep test</a:t>
             </a:r>
           </a:p>
           <a:p>
             <a:pPr>
-              <a:spcAft>
-                <a:spcPts val="800"/>
-              </a:spcAft>
-              <a:defRPr sz="2000">
-                <a:solidFill>
-                  <a:srgbClr val="445577"/>
-                </a:solidFill>
-              </a:defRPr>
+              <a:defRPr sz="2000"/>
             </a:pPr>
             <a:r>
-              <a:t>• Use bom.csv, sourcing.csv, and cut-list.csv before buying or cutting.</a:t>
+              <a:t>Soundboard deflection at no load, half tension, full tension, and 24 hours</a:t>
             </a:r>
           </a:p>
           <a:p>
             <a:pPr>
-              <a:spcAft>
-                <a:spcPts val="800"/>
-              </a:spcAft>
-              <a:defRPr sz="2000">
-                <a:solidFill>
-                  <a:srgbClr val="445577"/>
-                </a:solidFill>
-              </a:defRPr>
+              <a:defRPr sz="2000"/>
             </a:pPr>
             <a:r>
-              <a:t>• Use drawing-brief.md and CAD/CNC folders before machining.</a:t>
-            </a:r>
-          </a:p>
-          <a:p>
-            <a:pPr>
-              <a:spcAft>
-                <a:spcPts val="800"/>
-              </a:spcAft>
-              <a:defRPr sz="2000">
-                <a:solidFill>
-                  <a:srgbClr val="445577"/>
-                </a:solidFill>
-              </a:defRPr>
-            </a:pPr>
-            <a:r>
-              <a:t>• Print the packet for shopping, shop work, and validation.</a:t>
-            </a:r>
-          </a:p>
-        </p:txBody>
-      </p:sp>
-      <p:sp>
-        <p:nvSpPr>
-          <p:cNvPr id="5" name="TextBox 4"/>
-          <p:cNvSpPr txBox="1"/>
-          <p:nvPr/>
-        </p:nvSpPr>
-        <p:spPr>
-          <a:xfrm>
-            <a:off x="457200" y="6446520"/>
-            <a:ext cx="11247120" cy="274320"/>
-          </a:xfrm>
-          <a:prstGeom prst="rect">
-            <a:avLst/>
-          </a:prstGeom>
-          <a:noFill/>
-        </p:spPr>
-        <p:txBody>
-          <a:bodyPr wrap="none">
-            <a:spAutoFit/>
-          </a:bodyPr>
-          <a:lstStyle/>
-          <a:p>
-            <a:pPr>
-              <a:defRPr sz="1000">
-                <a:solidFill>
-                  <a:srgbClr val="445577"/>
-                </a:solidFill>
-              </a:defRPr>
-            </a:pPr>
-            <a:r>
-              <a:t>Lyre Build Packet  |  Slide 4 of 13</a:t>
+              <a:t>Full-size drawing or CAD detail before final frame cutting</a:t>
             </a:r>
           </a:p>
         </p:txBody>
@@ -4696,1082 +3418,61 @@
       <p:grpSpPr/>
       <p:sp>
         <p:nvSpPr>
-          <p:cNvPr id="2" name="Rectangle 1"/>
-          <p:cNvSpPr/>
-          <p:nvPr/>
-        </p:nvSpPr>
-        <p:spPr>
-          <a:xfrm>
-            <a:off x="0" y="0"/>
-            <a:ext cx="12191695" cy="411480"/>
-          </a:xfrm>
-          <a:prstGeom prst="rect">
-            <a:avLst/>
-          </a:prstGeom>
-          <a:solidFill>
-            <a:srgbClr val="1F3A68"/>
-          </a:solidFill>
-          <a:ln>
-            <a:noFill/>
-          </a:ln>
-        </p:spPr>
-        <p:style>
-          <a:lnRef idx="1">
-            <a:schemeClr val="accent1"/>
-          </a:lnRef>
-          <a:fillRef idx="3">
-            <a:schemeClr val="accent1"/>
-          </a:fillRef>
-          <a:effectRef idx="2">
-            <a:schemeClr val="accent1"/>
-          </a:effectRef>
-          <a:fontRef idx="minor">
-            <a:schemeClr val="lt1"/>
-          </a:fontRef>
-        </p:style>
-        <p:txBody>
-          <a:bodyPr rtlCol="0" anchor="ctr"/>
-          <a:lstStyle/>
-          <a:p>
-            <a:pPr algn="ctr"/>
-          </a:p>
-        </p:txBody>
-      </p:sp>
-      <p:sp>
-        <p:nvSpPr>
-          <p:cNvPr id="3" name="TextBox 2"/>
-          <p:cNvSpPr txBox="1"/>
-          <p:nvPr/>
-        </p:nvSpPr>
-        <p:spPr>
-          <a:xfrm>
-            <a:off x="457200" y="548640"/>
-            <a:ext cx="11247120" cy="914400"/>
-          </a:xfrm>
-          <a:prstGeom prst="rect">
-            <a:avLst/>
-          </a:prstGeom>
-          <a:noFill/>
-        </p:spPr>
-        <p:txBody>
-          <a:bodyPr wrap="square">
-            <a:spAutoFit/>
-          </a:bodyPr>
+          <p:cNvPr id="2" name="Title 1"/>
+          <p:cNvSpPr>
+            <a:spLocks noGrp="1"/>
+          </p:cNvSpPr>
+          <p:nvPr>
+            <p:ph type="title"/>
+          </p:nvPr>
+        </p:nvSpPr>
+        <p:spPr/>
+        <p:txBody>
+          <a:bodyPr/>
+          <a:lstStyle/>
+          <a:p>
+            <a:r>
+              <a:t>Next Actions</a:t>
+            </a:r>
+          </a:p>
+        </p:txBody>
+      </p:sp>
+      <p:sp>
+        <p:nvSpPr>
+          <p:cNvPr id="3" name="Content Placeholder 2"/>
+          <p:cNvSpPr>
+            <a:spLocks noGrp="1"/>
+          </p:cNvSpPr>
+          <p:nvPr>
+            <p:ph idx="1"/>
+          </p:nvPr>
+        </p:nvSpPr>
+        <p:spPr/>
+        <p:txBody>
+          <a:bodyPr/>
           <a:lstStyle/>
           <a:p>
             <a:pPr>
-              <a:defRPr sz="3000" b="1">
-                <a:solidFill>
-                  <a:srgbClr val="1F3A68"/>
-                </a:solidFill>
-              </a:defRPr>
+              <a:defRPr sz="2000"/>
             </a:pPr>
             <a:r>
-              <a:t>File Map</a:t>
-            </a:r>
-          </a:p>
-        </p:txBody>
-      </p:sp>
-      <p:sp>
-        <p:nvSpPr>
-          <p:cNvPr id="4" name="TextBox 3"/>
-          <p:cNvSpPr txBox="1"/>
-          <p:nvPr/>
-        </p:nvSpPr>
-        <p:spPr>
-          <a:xfrm>
-            <a:off x="457200" y="1463040"/>
-            <a:ext cx="11247120" cy="4754880"/>
-          </a:xfrm>
-          <a:prstGeom prst="rect">
-            <a:avLst/>
-          </a:prstGeom>
-          <a:noFill/>
-        </p:spPr>
-        <p:txBody>
-          <a:bodyPr wrap="square">
-            <a:spAutoFit/>
-          </a:bodyPr>
-          <a:lstStyle/>
+              <a:t>Resolve string stock from supplier or measured samples</a:t>
+            </a:r>
+          </a:p>
           <a:p>
             <a:pPr>
-              <a:spcAft>
-                <a:spcPts val="800"/>
-              </a:spcAft>
-              <a:defRPr sz="2000">
-                <a:solidFill>
-                  <a:srgbClr val="445577"/>
-                </a:solidFill>
-              </a:defRPr>
+              <a:defRPr sz="2000"/>
             </a:pPr>
             <a:r>
-              <a:t>• design.md: Project intent, catalog metadata, assumptions, and validation plan.</a:t>
+              <a:t>Review load path and pin edge distance</a:t>
             </a:r>
           </a:p>
           <a:p>
             <a:pPr>
-              <a:spcAft>
-                <a:spcPts val="800"/>
-              </a:spcAft>
-              <a:defRPr sz="2000">
-                <a:solidFill>
-                  <a:srgbClr val="445577"/>
-                </a:solidFill>
-              </a:defRPr>
+              <a:defRPr sz="2000"/>
             </a:pPr>
             <a:r>
-              <a:t>• bom.csv: Starter bill of materials with part categories, quantities, drawing refs, and notes.</a:t>
-            </a:r>
-          </a:p>
-          <a:p>
-            <a:pPr>
-              <a:spcAft>
-                <a:spcPts val="800"/>
-              </a:spcAft>
-              <a:defRPr sz="2000">
-                <a:solidFill>
-                  <a:srgbClr val="445577"/>
-                </a:solidFill>
-              </a:defRPr>
-            </a:pPr>
-            <a:r>
-              <a:t>• sourcing.csv: Supplier/search tracker with specs, price/date fields, lead time, substitutes, and risks.</a:t>
-            </a:r>
-          </a:p>
-          <a:p>
-            <a:pPr>
-              <a:spcAft>
-                <a:spcPts val="800"/>
-              </a:spcAft>
-              <a:defRPr sz="2000">
-                <a:solidFill>
-                  <a:srgbClr val="445577"/>
-                </a:solidFill>
-              </a:defRPr>
-            </a:pPr>
-            <a:r>
-              <a:t>• cut-list.csv: Rough/final stock sizes, material, grain/orientation, operations, yield, and offcuts.</a:t>
-            </a:r>
-          </a:p>
-          <a:p>
-            <a:pPr>
-              <a:spcAft>
-                <a:spcPts val="800"/>
-              </a:spcAft>
-              <a:defRPr sz="2000">
-                <a:solidFill>
-                  <a:srgbClr val="445577"/>
-                </a:solidFill>
-              </a:defRPr>
-            </a:pPr>
-            <a:r>
-              <a:t>• drawing-brief.md: Manufacturing drawing and technical product sketch brief.</a:t>
-            </a:r>
-          </a:p>
-          <a:p>
-            <a:pPr>
-              <a:spcAft>
-                <a:spcPts val="800"/>
-              </a:spcAft>
-              <a:defRPr sz="2000">
-                <a:solidFill>
-                  <a:srgbClr val="445577"/>
-                </a:solidFill>
-              </a:defRPr>
-            </a:pPr>
-            <a:r>
-              <a:t>• assembly-manual.md: Shop-facing sequence, tools, fixtures, safety, tuning, finishing, and maintenance notes.</a:t>
-            </a:r>
-          </a:p>
-          <a:p>
-            <a:pPr>
-              <a:spcAft>
-                <a:spcPts val="800"/>
-              </a:spcAft>
-              <a:defRPr sz="2000">
-                <a:solidFill>
-                  <a:srgbClr val="445577"/>
-                </a:solidFill>
-              </a:defRPr>
-            </a:pPr>
-            <a:r>
-              <a:t>• validation.csv: Target/measured values, tolerance, environment, result, and tuning/build action log.</a:t>
-            </a:r>
-          </a:p>
-          <a:p>
-            <a:pPr>
-              <a:spcAft>
-                <a:spcPts val="800"/>
-              </a:spcAft>
-              <a:defRPr sz="2000">
-                <a:solidFill>
-                  <a:srgbClr val="445577"/>
-                </a:solidFill>
-              </a:defRPr>
-            </a:pPr>
-            <a:r>
-              <a:t>• supplier-rfq.md: Supplier email/request-for-quote starter.</a:t>
-            </a:r>
-          </a:p>
-        </p:txBody>
-      </p:sp>
-      <p:sp>
-        <p:nvSpPr>
-          <p:cNvPr id="5" name="TextBox 4"/>
-          <p:cNvSpPr txBox="1"/>
-          <p:nvPr/>
-        </p:nvSpPr>
-        <p:spPr>
-          <a:xfrm>
-            <a:off x="457200" y="6446520"/>
-            <a:ext cx="11247120" cy="274320"/>
-          </a:xfrm>
-          <a:prstGeom prst="rect">
-            <a:avLst/>
-          </a:prstGeom>
-          <a:noFill/>
-        </p:spPr>
-        <p:txBody>
-          <a:bodyPr wrap="none">
-            <a:spAutoFit/>
-          </a:bodyPr>
-          <a:lstStyle/>
-          <a:p>
-            <a:pPr>
-              <a:defRPr sz="1000">
-                <a:solidFill>
-                  <a:srgbClr val="445577"/>
-                </a:solidFill>
-              </a:defRPr>
-            </a:pPr>
-            <a:r>
-              <a:t>Lyre Build Packet  |  Slide 5 of 13</a:t>
-            </a:r>
-          </a:p>
-        </p:txBody>
-      </p:sp>
-    </p:spTree>
-  </p:cSld>
-  <p:clrMapOvr>
-    <a:masterClrMapping/>
-  </p:clrMapOvr>
-</p:sld>
-</file>
-
-<file path=ppt/slides/slide6.xml><?xml version="1.0" encoding="utf-8"?>
-<p:sld xmlns:a="http://schemas.openxmlformats.org/drawingml/2006/main" xmlns:p="http://schemas.openxmlformats.org/presentationml/2006/main" xmlns:r="http://schemas.openxmlformats.org/officeDocument/2006/relationships">
-  <p:cSld>
-    <p:spTree>
-      <p:nvGrpSpPr>
-        <p:cNvPr id="1" name=""/>
-        <p:cNvGrpSpPr/>
-        <p:nvPr/>
-      </p:nvGrpSpPr>
-      <p:grpSpPr/>
-      <p:sp>
-        <p:nvSpPr>
-          <p:cNvPr id="2" name="Rectangle 1"/>
-          <p:cNvSpPr/>
-          <p:nvPr/>
-        </p:nvSpPr>
-        <p:spPr>
-          <a:xfrm>
-            <a:off x="0" y="0"/>
-            <a:ext cx="12191695" cy="411480"/>
-          </a:xfrm>
-          <a:prstGeom prst="rect">
-            <a:avLst/>
-          </a:prstGeom>
-          <a:solidFill>
-            <a:srgbClr val="1F3A68"/>
-          </a:solidFill>
-          <a:ln>
-            <a:noFill/>
-          </a:ln>
-        </p:spPr>
-        <p:style>
-          <a:lnRef idx="1">
-            <a:schemeClr val="accent1"/>
-          </a:lnRef>
-          <a:fillRef idx="3">
-            <a:schemeClr val="accent1"/>
-          </a:fillRef>
-          <a:effectRef idx="2">
-            <a:schemeClr val="accent1"/>
-          </a:effectRef>
-          <a:fontRef idx="minor">
-            <a:schemeClr val="lt1"/>
-          </a:fontRef>
-        </p:style>
-        <p:txBody>
-          <a:bodyPr rtlCol="0" anchor="ctr"/>
-          <a:lstStyle/>
-          <a:p>
-            <a:pPr algn="ctr"/>
-          </a:p>
-        </p:txBody>
-      </p:sp>
-      <p:sp>
-        <p:nvSpPr>
-          <p:cNvPr id="3" name="TextBox 2"/>
-          <p:cNvSpPr txBox="1"/>
-          <p:nvPr/>
-        </p:nvSpPr>
-        <p:spPr>
-          <a:xfrm>
-            <a:off x="457200" y="548640"/>
-            <a:ext cx="11247120" cy="914400"/>
-          </a:xfrm>
-          <a:prstGeom prst="rect">
-            <a:avLst/>
-          </a:prstGeom>
-          <a:noFill/>
-        </p:spPr>
-        <p:txBody>
-          <a:bodyPr wrap="square">
-            <a:spAutoFit/>
-          </a:bodyPr>
-          <a:lstStyle/>
-          <a:p>
-            <a:pPr>
-              <a:defRPr sz="3000" b="1">
-                <a:solidFill>
-                  <a:srgbClr val="1F3A68"/>
-                </a:solidFill>
-              </a:defRPr>
-            </a:pPr>
-            <a:r>
-              <a:t>Build Workflow</a:t>
-            </a:r>
-          </a:p>
-        </p:txBody>
-      </p:sp>
-      <p:sp>
-        <p:nvSpPr>
-          <p:cNvPr id="4" name="TextBox 3"/>
-          <p:cNvSpPr txBox="1"/>
-          <p:nvPr/>
-        </p:nvSpPr>
-        <p:spPr>
-          <a:xfrm>
-            <a:off x="457200" y="1463040"/>
-            <a:ext cx="11247120" cy="4754880"/>
-          </a:xfrm>
-          <a:prstGeom prst="rect">
-            <a:avLst/>
-          </a:prstGeom>
-          <a:noFill/>
-        </p:spPr>
-        <p:txBody>
-          <a:bodyPr wrap="square">
-            <a:spAutoFit/>
-          </a:bodyPr>
-          <a:lstStyle/>
-          <a:p>
-            <a:pPr>
-              <a:spcAft>
-                <a:spcPts val="800"/>
-              </a:spcAft>
-              <a:defRPr sz="2000">
-                <a:solidFill>
-                  <a:srgbClr val="445577"/>
-                </a:solidFill>
-              </a:defRPr>
-            </a:pPr>
-            <a:r>
-              <a:t>• Design and assumptions</a:t>
-            </a:r>
-          </a:p>
-          <a:p>
-            <a:pPr>
-              <a:spcAft>
-                <a:spcPts val="800"/>
-              </a:spcAft>
-              <a:defRPr sz="2000">
-                <a:solidFill>
-                  <a:srgbClr val="445577"/>
-                </a:solidFill>
-              </a:defRPr>
-            </a:pPr>
-            <a:r>
-              <a:t>• Source materials and hardware</a:t>
-            </a:r>
-          </a:p>
-          <a:p>
-            <a:pPr>
-              <a:spcAft>
-                <a:spcPts val="800"/>
-              </a:spcAft>
-              <a:defRPr sz="2000">
-                <a:solidFill>
-                  <a:srgbClr val="445577"/>
-                </a:solidFill>
-              </a:defRPr>
-            </a:pPr>
-            <a:r>
-              <a:t>• Prepare stock, fixtures, and CNC/laser/lathe setup</a:t>
-            </a:r>
-          </a:p>
-          <a:p>
-            <a:pPr>
-              <a:spcAft>
-                <a:spcPts val="800"/>
-              </a:spcAft>
-              <a:defRPr sz="2000">
-                <a:solidFill>
-                  <a:srgbClr val="445577"/>
-                </a:solidFill>
-              </a:defRPr>
-            </a:pPr>
-            <a:r>
-              <a:t>• Assemble, tune, finish, and validate</a:t>
-            </a:r>
-          </a:p>
-        </p:txBody>
-      </p:sp>
-      <p:sp>
-        <p:nvSpPr>
-          <p:cNvPr id="5" name="TextBox 4"/>
-          <p:cNvSpPr txBox="1"/>
-          <p:nvPr/>
-        </p:nvSpPr>
-        <p:spPr>
-          <a:xfrm>
-            <a:off x="457200" y="6446520"/>
-            <a:ext cx="11247120" cy="274320"/>
-          </a:xfrm>
-          <a:prstGeom prst="rect">
-            <a:avLst/>
-          </a:prstGeom>
-          <a:noFill/>
-        </p:spPr>
-        <p:txBody>
-          <a:bodyPr wrap="none">
-            <a:spAutoFit/>
-          </a:bodyPr>
-          <a:lstStyle/>
-          <a:p>
-            <a:pPr>
-              <a:defRPr sz="1000">
-                <a:solidFill>
-                  <a:srgbClr val="445577"/>
-                </a:solidFill>
-              </a:defRPr>
-            </a:pPr>
-            <a:r>
-              <a:t>Lyre Build Packet  |  Slide 6 of 13</a:t>
-            </a:r>
-          </a:p>
-        </p:txBody>
-      </p:sp>
-    </p:spTree>
-  </p:cSld>
-  <p:clrMapOvr>
-    <a:masterClrMapping/>
-  </p:clrMapOvr>
-</p:sld>
-</file>
-
-<file path=ppt/slides/slide7.xml><?xml version="1.0" encoding="utf-8"?>
-<p:sld xmlns:a="http://schemas.openxmlformats.org/drawingml/2006/main" xmlns:p="http://schemas.openxmlformats.org/presentationml/2006/main" xmlns:r="http://schemas.openxmlformats.org/officeDocument/2006/relationships">
-  <p:cSld>
-    <p:spTree>
-      <p:nvGrpSpPr>
-        <p:cNvPr id="1" name=""/>
-        <p:cNvGrpSpPr/>
-        <p:nvPr/>
-      </p:nvGrpSpPr>
-      <p:grpSpPr/>
-      <p:sp>
-        <p:nvSpPr>
-          <p:cNvPr id="2" name="Rectangle 1"/>
-          <p:cNvSpPr/>
-          <p:nvPr/>
-        </p:nvSpPr>
-        <p:spPr>
-          <a:xfrm>
-            <a:off x="0" y="0"/>
-            <a:ext cx="12191695" cy="411480"/>
-          </a:xfrm>
-          <a:prstGeom prst="rect">
-            <a:avLst/>
-          </a:prstGeom>
-          <a:solidFill>
-            <a:srgbClr val="1F3A68"/>
-          </a:solidFill>
-          <a:ln>
-            <a:noFill/>
-          </a:ln>
-        </p:spPr>
-        <p:style>
-          <a:lnRef idx="1">
-            <a:schemeClr val="accent1"/>
-          </a:lnRef>
-          <a:fillRef idx="3">
-            <a:schemeClr val="accent1"/>
-          </a:fillRef>
-          <a:effectRef idx="2">
-            <a:schemeClr val="accent1"/>
-          </a:effectRef>
-          <a:fontRef idx="minor">
-            <a:schemeClr val="lt1"/>
-          </a:fontRef>
-        </p:style>
-        <p:txBody>
-          <a:bodyPr rtlCol="0" anchor="ctr"/>
-          <a:lstStyle/>
-          <a:p>
-            <a:pPr algn="ctr"/>
-          </a:p>
-        </p:txBody>
-      </p:sp>
-      <p:sp>
-        <p:nvSpPr>
-          <p:cNvPr id="3" name="TextBox 2"/>
-          <p:cNvSpPr txBox="1"/>
-          <p:nvPr/>
-        </p:nvSpPr>
-        <p:spPr>
-          <a:xfrm>
-            <a:off x="457200" y="548640"/>
-            <a:ext cx="11247120" cy="914400"/>
-          </a:xfrm>
-          <a:prstGeom prst="rect">
-            <a:avLst/>
-          </a:prstGeom>
-          <a:noFill/>
-        </p:spPr>
-        <p:txBody>
-          <a:bodyPr wrap="square">
-            <a:spAutoFit/>
-          </a:bodyPr>
-          <a:lstStyle/>
-          <a:p>
-            <a:pPr>
-              <a:defRPr sz="3000" b="1">
-                <a:solidFill>
-                  <a:srgbClr val="1F3A68"/>
-                </a:solidFill>
-              </a:defRPr>
-            </a:pPr>
-            <a:r>
-              <a:t>Sourcing And BOM</a:t>
-            </a:r>
-          </a:p>
-        </p:txBody>
-      </p:sp>
-      <p:sp>
-        <p:nvSpPr>
-          <p:cNvPr id="4" name="TextBox 3"/>
-          <p:cNvSpPr txBox="1"/>
-          <p:nvPr/>
-        </p:nvSpPr>
-        <p:spPr>
-          <a:xfrm>
-            <a:off x="457200" y="1463040"/>
-            <a:ext cx="11247120" cy="4754880"/>
-          </a:xfrm>
-          <a:prstGeom prst="rect">
-            <a:avLst/>
-          </a:prstGeom>
-          <a:noFill/>
-        </p:spPr>
-        <p:txBody>
-          <a:bodyPr wrap="square">
-            <a:spAutoFit/>
-          </a:bodyPr>
-          <a:lstStyle/>
-          <a:p>
-            <a:pPr>
-              <a:spcAft>
-                <a:spcPts val="800"/>
-              </a:spcAft>
-              <a:defRPr sz="2000">
-                <a:solidFill>
-                  <a:srgbClr val="445577"/>
-                </a:solidFill>
-              </a:defRPr>
-            </a:pPr>
-            <a:r>
-              <a:t>• BOM gives part categories and drawing references.</a:t>
-            </a:r>
-          </a:p>
-          <a:p>
-            <a:pPr>
-              <a:spcAft>
-                <a:spcPts val="800"/>
-              </a:spcAft>
-              <a:defRPr sz="2000">
-                <a:solidFill>
-                  <a:srgbClr val="445577"/>
-                </a:solidFill>
-              </a:defRPr>
-            </a:pPr>
-            <a:r>
-              <a:t>• Sourcing tracks search terms, supplier candidates, price/date, lead time, substitutions.</a:t>
-            </a:r>
-          </a:p>
-          <a:p>
-            <a:pPr>
-              <a:spcAft>
-                <a:spcPts val="800"/>
-              </a:spcAft>
-              <a:defRPr sz="2000">
-                <a:solidFill>
-                  <a:srgbClr val="445577"/>
-                </a:solidFill>
-              </a:defRPr>
-            </a:pPr>
-            <a:r>
-              <a:t>• Visual BOM brief turns the parts list into a presentation-ready image board.</a:t>
-            </a:r>
-          </a:p>
-        </p:txBody>
-      </p:sp>
-      <p:sp>
-        <p:nvSpPr>
-          <p:cNvPr id="5" name="TextBox 4"/>
-          <p:cNvSpPr txBox="1"/>
-          <p:nvPr/>
-        </p:nvSpPr>
-        <p:spPr>
-          <a:xfrm>
-            <a:off x="457200" y="6446520"/>
-            <a:ext cx="11247120" cy="274320"/>
-          </a:xfrm>
-          <a:prstGeom prst="rect">
-            <a:avLst/>
-          </a:prstGeom>
-          <a:noFill/>
-        </p:spPr>
-        <p:txBody>
-          <a:bodyPr wrap="none">
-            <a:spAutoFit/>
-          </a:bodyPr>
-          <a:lstStyle/>
-          <a:p>
-            <a:pPr>
-              <a:defRPr sz="1000">
-                <a:solidFill>
-                  <a:srgbClr val="445577"/>
-                </a:solidFill>
-              </a:defRPr>
-            </a:pPr>
-            <a:r>
-              <a:t>Lyre Build Packet  |  Slide 7 of 13</a:t>
-            </a:r>
-          </a:p>
-        </p:txBody>
-      </p:sp>
-    </p:spTree>
-  </p:cSld>
-  <p:clrMapOvr>
-    <a:masterClrMapping/>
-  </p:clrMapOvr>
-</p:sld>
-</file>
-
-<file path=ppt/slides/slide8.xml><?xml version="1.0" encoding="utf-8"?>
-<p:sld xmlns:a="http://schemas.openxmlformats.org/drawingml/2006/main" xmlns:p="http://schemas.openxmlformats.org/presentationml/2006/main" xmlns:r="http://schemas.openxmlformats.org/officeDocument/2006/relationships">
-  <p:cSld>
-    <p:spTree>
-      <p:nvGrpSpPr>
-        <p:cNvPr id="1" name=""/>
-        <p:cNvGrpSpPr/>
-        <p:nvPr/>
-      </p:nvGrpSpPr>
-      <p:grpSpPr/>
-      <p:sp>
-        <p:nvSpPr>
-          <p:cNvPr id="2" name="Rectangle 1"/>
-          <p:cNvSpPr/>
-          <p:nvPr/>
-        </p:nvSpPr>
-        <p:spPr>
-          <a:xfrm>
-            <a:off x="0" y="0"/>
-            <a:ext cx="12191695" cy="411480"/>
-          </a:xfrm>
-          <a:prstGeom prst="rect">
-            <a:avLst/>
-          </a:prstGeom>
-          <a:solidFill>
-            <a:srgbClr val="1F3A68"/>
-          </a:solidFill>
-          <a:ln>
-            <a:noFill/>
-          </a:ln>
-        </p:spPr>
-        <p:style>
-          <a:lnRef idx="1">
-            <a:schemeClr val="accent1"/>
-          </a:lnRef>
-          <a:fillRef idx="3">
-            <a:schemeClr val="accent1"/>
-          </a:fillRef>
-          <a:effectRef idx="2">
-            <a:schemeClr val="accent1"/>
-          </a:effectRef>
-          <a:fontRef idx="minor">
-            <a:schemeClr val="lt1"/>
-          </a:fontRef>
-        </p:style>
-        <p:txBody>
-          <a:bodyPr rtlCol="0" anchor="ctr"/>
-          <a:lstStyle/>
-          <a:p>
-            <a:pPr algn="ctr"/>
-          </a:p>
-        </p:txBody>
-      </p:sp>
-      <p:sp>
-        <p:nvSpPr>
-          <p:cNvPr id="3" name="TextBox 2"/>
-          <p:cNvSpPr txBox="1"/>
-          <p:nvPr/>
-        </p:nvSpPr>
-        <p:spPr>
-          <a:xfrm>
-            <a:off x="457200" y="548640"/>
-            <a:ext cx="11247120" cy="914400"/>
-          </a:xfrm>
-          <a:prstGeom prst="rect">
-            <a:avLst/>
-          </a:prstGeom>
-          <a:noFill/>
-        </p:spPr>
-        <p:txBody>
-          <a:bodyPr wrap="square">
-            <a:spAutoFit/>
-          </a:bodyPr>
-          <a:lstStyle/>
-          <a:p>
-            <a:pPr>
-              <a:defRPr sz="3000" b="1">
-                <a:solidFill>
-                  <a:srgbClr val="1F3A68"/>
-                </a:solidFill>
-              </a:defRPr>
-            </a:pPr>
-            <a:r>
-              <a:t>Shop Packet</a:t>
-            </a:r>
-          </a:p>
-        </p:txBody>
-      </p:sp>
-      <p:sp>
-        <p:nvSpPr>
-          <p:cNvPr id="4" name="TextBox 3"/>
-          <p:cNvSpPr txBox="1"/>
-          <p:nvPr/>
-        </p:nvSpPr>
-        <p:spPr>
-          <a:xfrm>
-            <a:off x="457200" y="1463040"/>
-            <a:ext cx="11247120" cy="4754880"/>
-          </a:xfrm>
-          <a:prstGeom prst="rect">
-            <a:avLst/>
-          </a:prstGeom>
-          <a:noFill/>
-        </p:spPr>
-        <p:txBody>
-          <a:bodyPr wrap="square">
-            <a:spAutoFit/>
-          </a:bodyPr>
-          <a:lstStyle/>
-          <a:p>
-            <a:pPr>
-              <a:spcAft>
-                <a:spcPts val="800"/>
-              </a:spcAft>
-              <a:defRPr sz="2000">
-                <a:solidFill>
-                  <a:srgbClr val="445577"/>
-                </a:solidFill>
-              </a:defRPr>
-            </a:pPr>
-            <a:r>
-              <a:t>• Cut list for lumber/sheet/blank planning.</a:t>
-            </a:r>
-          </a:p>
-          <a:p>
-            <a:pPr>
-              <a:spcAft>
-                <a:spcPts val="800"/>
-              </a:spcAft>
-              <a:defRPr sz="2000">
-                <a:solidFill>
-                  <a:srgbClr val="445577"/>
-                </a:solidFill>
-              </a:defRPr>
-            </a:pPr>
-            <a:r>
-              <a:t>• Assembly manual for away-from-keyboard work.</a:t>
-            </a:r>
-          </a:p>
-          <a:p>
-            <a:pPr>
-              <a:spcAft>
-                <a:spcPts val="800"/>
-              </a:spcAft>
-              <a:defRPr sz="2000">
-                <a:solidFill>
-                  <a:srgbClr val="445577"/>
-                </a:solidFill>
-              </a:defRPr>
-            </a:pPr>
-            <a:r>
-              <a:t>• Validation sheet for measured dimensions, tuning, pass/fail checks.</a:t>
-            </a:r>
-          </a:p>
-        </p:txBody>
-      </p:sp>
-      <p:sp>
-        <p:nvSpPr>
-          <p:cNvPr id="5" name="TextBox 4"/>
-          <p:cNvSpPr txBox="1"/>
-          <p:nvPr/>
-        </p:nvSpPr>
-        <p:spPr>
-          <a:xfrm>
-            <a:off x="457200" y="6446520"/>
-            <a:ext cx="11247120" cy="274320"/>
-          </a:xfrm>
-          <a:prstGeom prst="rect">
-            <a:avLst/>
-          </a:prstGeom>
-          <a:noFill/>
-        </p:spPr>
-        <p:txBody>
-          <a:bodyPr wrap="none">
-            <a:spAutoFit/>
-          </a:bodyPr>
-          <a:lstStyle/>
-          <a:p>
-            <a:pPr>
-              <a:defRPr sz="1000">
-                <a:solidFill>
-                  <a:srgbClr val="445577"/>
-                </a:solidFill>
-              </a:defRPr>
-            </a:pPr>
-            <a:r>
-              <a:t>Lyre Build Packet  |  Slide 8 of 13</a:t>
-            </a:r>
-          </a:p>
-        </p:txBody>
-      </p:sp>
-    </p:spTree>
-  </p:cSld>
-  <p:clrMapOvr>
-    <a:masterClrMapping/>
-  </p:clrMapOvr>
-</p:sld>
-</file>
-
-<file path=ppt/slides/slide9.xml><?xml version="1.0" encoding="utf-8"?>
-<p:sld xmlns:a="http://schemas.openxmlformats.org/drawingml/2006/main" xmlns:p="http://schemas.openxmlformats.org/presentationml/2006/main" xmlns:r="http://schemas.openxmlformats.org/officeDocument/2006/relationships">
-  <p:cSld>
-    <p:spTree>
-      <p:nvGrpSpPr>
-        <p:cNvPr id="1" name=""/>
-        <p:cNvGrpSpPr/>
-        <p:nvPr/>
-      </p:nvGrpSpPr>
-      <p:grpSpPr/>
-      <p:sp>
-        <p:nvSpPr>
-          <p:cNvPr id="2" name="Rectangle 1"/>
-          <p:cNvSpPr/>
-          <p:nvPr/>
-        </p:nvSpPr>
-        <p:spPr>
-          <a:xfrm>
-            <a:off x="0" y="0"/>
-            <a:ext cx="12191695" cy="411480"/>
-          </a:xfrm>
-          <a:prstGeom prst="rect">
-            <a:avLst/>
-          </a:prstGeom>
-          <a:solidFill>
-            <a:srgbClr val="1F3A68"/>
-          </a:solidFill>
-          <a:ln>
-            <a:noFill/>
-          </a:ln>
-        </p:spPr>
-        <p:style>
-          <a:lnRef idx="1">
-            <a:schemeClr val="accent1"/>
-          </a:lnRef>
-          <a:fillRef idx="3">
-            <a:schemeClr val="accent1"/>
-          </a:fillRef>
-          <a:effectRef idx="2">
-            <a:schemeClr val="accent1"/>
-          </a:effectRef>
-          <a:fontRef idx="minor">
-            <a:schemeClr val="lt1"/>
-          </a:fontRef>
-        </p:style>
-        <p:txBody>
-          <a:bodyPr rtlCol="0" anchor="ctr"/>
-          <a:lstStyle/>
-          <a:p>
-            <a:pPr algn="ctr"/>
-          </a:p>
-        </p:txBody>
-      </p:sp>
-      <p:sp>
-        <p:nvSpPr>
-          <p:cNvPr id="3" name="TextBox 2"/>
-          <p:cNvSpPr txBox="1"/>
-          <p:nvPr/>
-        </p:nvSpPr>
-        <p:spPr>
-          <a:xfrm>
-            <a:off x="457200" y="548640"/>
-            <a:ext cx="11247120" cy="914400"/>
-          </a:xfrm>
-          <a:prstGeom prst="rect">
-            <a:avLst/>
-          </a:prstGeom>
-          <a:noFill/>
-        </p:spPr>
-        <p:txBody>
-          <a:bodyPr wrap="square">
-            <a:spAutoFit/>
-          </a:bodyPr>
-          <a:lstStyle/>
-          <a:p>
-            <a:pPr>
-              <a:defRPr sz="3000" b="1">
-                <a:solidFill>
-                  <a:srgbClr val="1F3A68"/>
-                </a:solidFill>
-              </a:defRPr>
-            </a:pPr>
-            <a:r>
-              <a:t>Drawings, CAD, CNC</a:t>
-            </a:r>
-          </a:p>
-        </p:txBody>
-      </p:sp>
-      <p:sp>
-        <p:nvSpPr>
-          <p:cNvPr id="4" name="TextBox 3"/>
-          <p:cNvSpPr txBox="1"/>
-          <p:nvPr/>
-        </p:nvSpPr>
-        <p:spPr>
-          <a:xfrm>
-            <a:off x="457200" y="1463040"/>
-            <a:ext cx="11247120" cy="4754880"/>
-          </a:xfrm>
-          <a:prstGeom prst="rect">
-            <a:avLst/>
-          </a:prstGeom>
-          <a:noFill/>
-        </p:spPr>
-        <p:txBody>
-          <a:bodyPr wrap="square">
-            <a:spAutoFit/>
-          </a:bodyPr>
-          <a:lstStyle/>
-          <a:p>
-            <a:pPr>
-              <a:spcAft>
-                <a:spcPts val="800"/>
-              </a:spcAft>
-              <a:defRPr sz="2000">
-                <a:solidFill>
-                  <a:srgbClr val="445577"/>
-                </a:solidFill>
-              </a:defRPr>
-            </a:pPr>
-            <a:r>
-              <a:t>• drawing-brief.md defines required views, dimensions, datums, sketch intent.</a:t>
-            </a:r>
-          </a:p>
-          <a:p>
-            <a:pPr>
-              <a:spcAft>
-                <a:spcPts val="800"/>
-              </a:spcAft>
-              <a:defRPr sz="2000">
-                <a:solidFill>
-                  <a:srgbClr val="445577"/>
-                </a:solidFill>
-              </a:defRPr>
-            </a:pPr>
-            <a:r>
-              <a:t>• cad/ holds models and design tables.</a:t>
-            </a:r>
-          </a:p>
-          <a:p>
-            <a:pPr>
-              <a:spcAft>
-                <a:spcPts val="800"/>
-              </a:spcAft>
-              <a:defRPr sz="2000">
-                <a:solidFill>
-                  <a:srgbClr val="445577"/>
-                </a:solidFill>
-              </a:defRPr>
-            </a:pPr>
-            <a:r>
-              <a:t>• cnc/ holds CAM, toolpaths, setup sheets, dry-run notes.</a:t>
-            </a:r>
-          </a:p>
-          <a:p>
-            <a:pPr>
-              <a:spcAft>
-                <a:spcPts val="800"/>
-              </a:spcAft>
-              <a:defRPr sz="2000">
-                <a:solidFill>
-                  <a:srgbClr val="445577"/>
-                </a:solidFill>
-              </a:defRPr>
-            </a:pPr>
-            <a:r>
-              <a:t>• drawings/ holds PDFs, SVGs, DXFs, drawing exports.</a:t>
-            </a:r>
-          </a:p>
-        </p:txBody>
-      </p:sp>
-      <p:sp>
-        <p:nvSpPr>
-          <p:cNvPr id="5" name="TextBox 4"/>
-          <p:cNvSpPr txBox="1"/>
-          <p:nvPr/>
-        </p:nvSpPr>
-        <p:spPr>
-          <a:xfrm>
-            <a:off x="457200" y="6446520"/>
-            <a:ext cx="11247120" cy="274320"/>
-          </a:xfrm>
-          <a:prstGeom prst="rect">
-            <a:avLst/>
-          </a:prstGeom>
-          <a:noFill/>
-        </p:spPr>
-        <p:txBody>
-          <a:bodyPr wrap="none">
-            <a:spAutoFit/>
-          </a:bodyPr>
-          <a:lstStyle/>
-          <a:p>
-            <a:pPr>
-              <a:defRPr sz="1000">
-                <a:solidFill>
-                  <a:srgbClr val="445577"/>
-                </a:solidFill>
-              </a:defRPr>
-            </a:pPr>
-            <a:r>
-              <a:t>Lyre Build Packet  |  Slide 9 of 13</a:t>
+              <a:t>Record first pitch-up log and prototype photos before readiness promotion</a:t>
             </a:r>
           </a:p>
         </p:txBody>

</xml_diff>

<commit_message>
Add lyre string and load evidence gates (#5)
Co-authored-by: AI Bot <bot@example.com>
</commit_message>
<xml_diff>
--- a/capstone-deck.pptx
+++ b/capstone-deck.pptx
@@ -10,16 +10,8 @@
     <p:sldId id="258" r:id="rId9"/>
     <p:sldId id="259" r:id="rId10"/>
     <p:sldId id="260" r:id="rId11"/>
-    <p:sldId id="261" r:id="rId12"/>
-    <p:sldId id="262" r:id="rId13"/>
-    <p:sldId id="263" r:id="rId14"/>
-    <p:sldId id="264" r:id="rId15"/>
-    <p:sldId id="265" r:id="rId16"/>
-    <p:sldId id="266" r:id="rId17"/>
-    <p:sldId id="267" r:id="rId18"/>
-    <p:sldId id="268" r:id="rId19"/>
   </p:sldIdLst>
-  <p:sldSz cx="12191695" cy="6858000" type="screen4x3"/>
+  <p:sldSz cx="9144000" cy="6858000" type="screen4x3"/>
   <p:notesSz cx="6858000" cy="9144000"/>
   <p:defaultTextStyle>
     <a:defPPr>
@@ -3102,992 +3094,61 @@
       <p:grpSpPr/>
       <p:sp>
         <p:nvSpPr>
-          <p:cNvPr id="2" name="Rectangle 1"/>
-          <p:cNvSpPr/>
-          <p:nvPr/>
-        </p:nvSpPr>
-        <p:spPr>
-          <a:xfrm>
-            <a:off x="0" y="0"/>
-            <a:ext cx="12191695" cy="411480"/>
-          </a:xfrm>
-          <a:prstGeom prst="rect">
-            <a:avLst/>
-          </a:prstGeom>
-          <a:solidFill>
-            <a:srgbClr val="1F3A68"/>
-          </a:solidFill>
-          <a:ln>
-            <a:noFill/>
-          </a:ln>
-        </p:spPr>
-        <p:style>
-          <a:lnRef idx="1">
-            <a:schemeClr val="accent1"/>
-          </a:lnRef>
-          <a:fillRef idx="3">
-            <a:schemeClr val="accent1"/>
-          </a:fillRef>
-          <a:effectRef idx="2">
-            <a:schemeClr val="accent1"/>
-          </a:effectRef>
-          <a:fontRef idx="minor">
-            <a:schemeClr val="lt1"/>
-          </a:fontRef>
-        </p:style>
-        <p:txBody>
-          <a:bodyPr rtlCol="0" anchor="ctr"/>
-          <a:lstStyle/>
-          <a:p>
-            <a:pPr algn="ctr"/>
-          </a:p>
-        </p:txBody>
-      </p:sp>
-      <p:sp>
-        <p:nvSpPr>
-          <p:cNvPr id="3" name="TextBox 2"/>
-          <p:cNvSpPr txBox="1"/>
-          <p:nvPr/>
-        </p:nvSpPr>
-        <p:spPr>
-          <a:xfrm>
-            <a:off x="457200" y="548640"/>
-            <a:ext cx="11247120" cy="914400"/>
-          </a:xfrm>
-          <a:prstGeom prst="rect">
-            <a:avLst/>
-          </a:prstGeom>
-          <a:noFill/>
-        </p:spPr>
-        <p:txBody>
-          <a:bodyPr wrap="square">
-            <a:spAutoFit/>
-          </a:bodyPr>
+          <p:cNvPr id="2" name="Title 1"/>
+          <p:cNvSpPr>
+            <a:spLocks noGrp="1"/>
+          </p:cNvSpPr>
+          <p:nvPr>
+            <p:ph type="title"/>
+          </p:nvPr>
+        </p:nvSpPr>
+        <p:spPr/>
+        <p:txBody>
+          <a:bodyPr/>
+          <a:lstStyle/>
+          <a:p>
+            <a:r>
+              <a:t>Lyre Build Packet</a:t>
+            </a:r>
+          </a:p>
+        </p:txBody>
+      </p:sp>
+      <p:sp>
+        <p:nvSpPr>
+          <p:cNvPr id="3" name="Content Placeholder 2"/>
+          <p:cNvSpPr>
+            <a:spLocks noGrp="1"/>
+          </p:cNvSpPr>
+          <p:nvPr>
+            <p:ph idx="1"/>
+          </p:nvPr>
+        </p:nvSpPr>
+        <p:spPr/>
+        <p:txBody>
+          <a:bodyPr/>
           <a:lstStyle/>
           <a:p>
             <a:pPr>
-              <a:defRPr sz="3600" b="1">
-                <a:solidFill>
-                  <a:srgbClr val="1F3A68"/>
-                </a:solidFill>
-              </a:defRPr>
+              <a:defRPr sz="2000"/>
             </a:pPr>
             <a:r>
-              <a:t>Lyre Build Packet</a:t>
-            </a:r>
-          </a:p>
-        </p:txBody>
-      </p:sp>
-      <p:sp>
-        <p:nvSpPr>
-          <p:cNvPr id="4" name="TextBox 3"/>
-          <p:cNvSpPr txBox="1"/>
-          <p:nvPr/>
-        </p:nvSpPr>
-        <p:spPr>
-          <a:xfrm>
-            <a:off x="457200" y="1554480"/>
-            <a:ext cx="11247120" cy="4754880"/>
-          </a:xfrm>
-          <a:prstGeom prst="rect">
-            <a:avLst/>
-          </a:prstGeom>
-          <a:noFill/>
-        </p:spPr>
-        <p:txBody>
-          <a:bodyPr wrap="square">
-            <a:spAutoFit/>
-          </a:bodyPr>
-          <a:lstStyle/>
+              <a:t>Prototype-planning scaffold</a:t>
+            </a:r>
+          </a:p>
           <a:p>
             <a:pPr>
-              <a:spcAft>
-                <a:spcPts val="800"/>
-              </a:spcAft>
-              <a:defRPr sz="2200">
-                <a:solidFill>
-                  <a:srgbClr val="111111"/>
-                </a:solidFill>
-              </a:defRPr>
+              <a:defRPr sz="2000"/>
             </a:pPr>
             <a:r>
-              <a:t>Musical instrument documentation capstone</a:t>
+              <a:t>Compact 10-string plucked lyre</a:t>
             </a:r>
           </a:p>
           <a:p>
             <a:pPr>
-              <a:spcAft>
-                <a:spcPts val="800"/>
-              </a:spcAft>
-              <a:defRPr sz="2200">
-                <a:solidFill>
-                  <a:srgbClr val="111111"/>
-                </a:solidFill>
-              </a:defRPr>
+              <a:defRPr sz="2000"/>
             </a:pPr>
             <a:r>
-              <a:t>Build packet: lyre-codex-gina-r2-build-packet</a:t>
-            </a:r>
-          </a:p>
-          <a:p>
-            <a:pPr>
-              <a:spcAft>
-                <a:spcPts val="800"/>
-              </a:spcAft>
-              <a:defRPr sz="2200">
-                <a:solidFill>
-                  <a:srgbClr val="111111"/>
-                </a:solidFill>
-              </a:defRPr>
-            </a:pPr>
-            <a:r>
-              <a:t>Generated: 2026-05-09</a:t>
-            </a:r>
-          </a:p>
-        </p:txBody>
-      </p:sp>
-      <p:sp>
-        <p:nvSpPr>
-          <p:cNvPr id="5" name="TextBox 4"/>
-          <p:cNvSpPr txBox="1"/>
-          <p:nvPr/>
-        </p:nvSpPr>
-        <p:spPr>
-          <a:xfrm>
-            <a:off x="457200" y="6446520"/>
-            <a:ext cx="11247120" cy="274320"/>
-          </a:xfrm>
-          <a:prstGeom prst="rect">
-            <a:avLst/>
-          </a:prstGeom>
-          <a:noFill/>
-        </p:spPr>
-        <p:txBody>
-          <a:bodyPr wrap="none">
-            <a:spAutoFit/>
-          </a:bodyPr>
-          <a:lstStyle/>
-          <a:p>
-            <a:pPr>
-              <a:defRPr sz="1000">
-                <a:solidFill>
-                  <a:srgbClr val="445577"/>
-                </a:solidFill>
-              </a:defRPr>
-            </a:pPr>
-            <a:r>
-              <a:t>Lyre Build Packet  |  Slide 1 of 13</a:t>
-            </a:r>
-          </a:p>
-        </p:txBody>
-      </p:sp>
-    </p:spTree>
-  </p:cSld>
-  <p:clrMapOvr>
-    <a:masterClrMapping/>
-  </p:clrMapOvr>
-</p:sld>
-</file>
-
-<file path=ppt/slides/slide10.xml><?xml version="1.0" encoding="utf-8"?>
-<p:sld xmlns:a="http://schemas.openxmlformats.org/drawingml/2006/main" xmlns:p="http://schemas.openxmlformats.org/presentationml/2006/main" xmlns:r="http://schemas.openxmlformats.org/officeDocument/2006/relationships">
-  <p:cSld>
-    <p:spTree>
-      <p:nvGrpSpPr>
-        <p:cNvPr id="1" name=""/>
-        <p:cNvGrpSpPr/>
-        <p:nvPr/>
-      </p:nvGrpSpPr>
-      <p:grpSpPr/>
-      <p:sp>
-        <p:nvSpPr>
-          <p:cNvPr id="2" name="Rectangle 1"/>
-          <p:cNvSpPr/>
-          <p:nvPr/>
-        </p:nvSpPr>
-        <p:spPr>
-          <a:xfrm>
-            <a:off x="0" y="0"/>
-            <a:ext cx="12191695" cy="411480"/>
-          </a:xfrm>
-          <a:prstGeom prst="rect">
-            <a:avLst/>
-          </a:prstGeom>
-          <a:solidFill>
-            <a:srgbClr val="1F3A68"/>
-          </a:solidFill>
-          <a:ln>
-            <a:noFill/>
-          </a:ln>
-        </p:spPr>
-        <p:style>
-          <a:lnRef idx="1">
-            <a:schemeClr val="accent1"/>
-          </a:lnRef>
-          <a:fillRef idx="3">
-            <a:schemeClr val="accent1"/>
-          </a:fillRef>
-          <a:effectRef idx="2">
-            <a:schemeClr val="accent1"/>
-          </a:effectRef>
-          <a:fontRef idx="minor">
-            <a:schemeClr val="lt1"/>
-          </a:fontRef>
-        </p:style>
-        <p:txBody>
-          <a:bodyPr rtlCol="0" anchor="ctr"/>
-          <a:lstStyle/>
-          <a:p>
-            <a:pPr algn="ctr"/>
-          </a:p>
-        </p:txBody>
-      </p:sp>
-      <p:sp>
-        <p:nvSpPr>
-          <p:cNvPr id="3" name="TextBox 2"/>
-          <p:cNvSpPr txBox="1"/>
-          <p:nvPr/>
-        </p:nvSpPr>
-        <p:spPr>
-          <a:xfrm>
-            <a:off x="457200" y="548640"/>
-            <a:ext cx="11247120" cy="914400"/>
-          </a:xfrm>
-          <a:prstGeom prst="rect">
-            <a:avLst/>
-          </a:prstGeom>
-          <a:noFill/>
-        </p:spPr>
-        <p:txBody>
-          <a:bodyPr wrap="square">
-            <a:spAutoFit/>
-          </a:bodyPr>
-          <a:lstStyle/>
-          <a:p>
-            <a:pPr>
-              <a:defRPr sz="3000" b="1">
-                <a:solidFill>
-                  <a:srgbClr val="1F3A68"/>
-                </a:solidFill>
-              </a:defRPr>
-            </a:pPr>
-            <a:r>
-              <a:t>Images And Screenshots</a:t>
-            </a:r>
-          </a:p>
-        </p:txBody>
-      </p:sp>
-      <p:sp>
-        <p:nvSpPr>
-          <p:cNvPr id="4" name="TextBox 3"/>
-          <p:cNvSpPr txBox="1"/>
-          <p:nvPr/>
-        </p:nvSpPr>
-        <p:spPr>
-          <a:xfrm>
-            <a:off x="457200" y="1463040"/>
-            <a:ext cx="5943600" cy="4754880"/>
-          </a:xfrm>
-          <a:prstGeom prst="rect">
-            <a:avLst/>
-          </a:prstGeom>
-          <a:noFill/>
-        </p:spPr>
-        <p:txBody>
-          <a:bodyPr wrap="square">
-            <a:spAutoFit/>
-          </a:bodyPr>
-          <a:lstStyle/>
-          <a:p>
-            <a:pPr>
-              <a:spcAft>
-                <a:spcPts val="800"/>
-              </a:spcAft>
-              <a:defRPr sz="2000">
-                <a:solidFill>
-                  <a:srgbClr val="445577"/>
-                </a:solidFill>
-              </a:defRPr>
-            </a:pPr>
-            <a:r>
-              <a:t>• images/P-Lyre-Harp-1200x1200-1_1080xinspiration.webp</a:t>
-            </a:r>
-          </a:p>
-        </p:txBody>
-      </p:sp>
-      <p:sp>
-        <p:nvSpPr>
-          <p:cNvPr id="5" name="TextBox 4"/>
-          <p:cNvSpPr txBox="1"/>
-          <p:nvPr/>
-        </p:nvSpPr>
-        <p:spPr>
-          <a:xfrm>
-            <a:off x="457200" y="6446520"/>
-            <a:ext cx="11247120" cy="274320"/>
-          </a:xfrm>
-          <a:prstGeom prst="rect">
-            <a:avLst/>
-          </a:prstGeom>
-          <a:noFill/>
-        </p:spPr>
-        <p:txBody>
-          <a:bodyPr wrap="none">
-            <a:spAutoFit/>
-          </a:bodyPr>
-          <a:lstStyle/>
-          <a:p>
-            <a:pPr>
-              <a:defRPr sz="1000">
-                <a:solidFill>
-                  <a:srgbClr val="445577"/>
-                </a:solidFill>
-              </a:defRPr>
-            </a:pPr>
-            <a:r>
-              <a:t>Lyre Build Packet  |  Slide 10 of 13</a:t>
-            </a:r>
-          </a:p>
-        </p:txBody>
-      </p:sp>
-    </p:spTree>
-  </p:cSld>
-  <p:clrMapOvr>
-    <a:masterClrMapping/>
-  </p:clrMapOvr>
-</p:sld>
-</file>
-
-<file path=ppt/slides/slide11.xml><?xml version="1.0" encoding="utf-8"?>
-<p:sld xmlns:a="http://schemas.openxmlformats.org/drawingml/2006/main" xmlns:p="http://schemas.openxmlformats.org/presentationml/2006/main" xmlns:r="http://schemas.openxmlformats.org/officeDocument/2006/relationships">
-  <p:cSld>
-    <p:spTree>
-      <p:nvGrpSpPr>
-        <p:cNvPr id="1" name=""/>
-        <p:cNvGrpSpPr/>
-        <p:nvPr/>
-      </p:nvGrpSpPr>
-      <p:grpSpPr/>
-      <p:sp>
-        <p:nvSpPr>
-          <p:cNvPr id="2" name="Rectangle 1"/>
-          <p:cNvSpPr/>
-          <p:nvPr/>
-        </p:nvSpPr>
-        <p:spPr>
-          <a:xfrm>
-            <a:off x="0" y="0"/>
-            <a:ext cx="12191695" cy="411480"/>
-          </a:xfrm>
-          <a:prstGeom prst="rect">
-            <a:avLst/>
-          </a:prstGeom>
-          <a:solidFill>
-            <a:srgbClr val="1F3A68"/>
-          </a:solidFill>
-          <a:ln>
-            <a:noFill/>
-          </a:ln>
-        </p:spPr>
-        <p:style>
-          <a:lnRef idx="1">
-            <a:schemeClr val="accent1"/>
-          </a:lnRef>
-          <a:fillRef idx="3">
-            <a:schemeClr val="accent1"/>
-          </a:fillRef>
-          <a:effectRef idx="2">
-            <a:schemeClr val="accent1"/>
-          </a:effectRef>
-          <a:fontRef idx="minor">
-            <a:schemeClr val="lt1"/>
-          </a:fontRef>
-        </p:style>
-        <p:txBody>
-          <a:bodyPr rtlCol="0" anchor="ctr"/>
-          <a:lstStyle/>
-          <a:p>
-            <a:pPr algn="ctr"/>
-          </a:p>
-        </p:txBody>
-      </p:sp>
-      <p:sp>
-        <p:nvSpPr>
-          <p:cNvPr id="3" name="TextBox 2"/>
-          <p:cNvSpPr txBox="1"/>
-          <p:nvPr/>
-        </p:nvSpPr>
-        <p:spPr>
-          <a:xfrm>
-            <a:off x="457200" y="548640"/>
-            <a:ext cx="11247120" cy="914400"/>
-          </a:xfrm>
-          <a:prstGeom prst="rect">
-            <a:avLst/>
-          </a:prstGeom>
-          <a:noFill/>
-        </p:spPr>
-        <p:txBody>
-          <a:bodyPr wrap="square">
-            <a:spAutoFit/>
-          </a:bodyPr>
-          <a:lstStyle/>
-          <a:p>
-            <a:pPr>
-              <a:defRPr sz="3000" b="1">
-                <a:solidFill>
-                  <a:srgbClr val="1F3A68"/>
-                </a:solidFill>
-              </a:defRPr>
-            </a:pPr>
-            <a:r>
-              <a:t>Validation Plan</a:t>
-            </a:r>
-          </a:p>
-        </p:txBody>
-      </p:sp>
-      <p:sp>
-        <p:nvSpPr>
-          <p:cNvPr id="4" name="TextBox 3"/>
-          <p:cNvSpPr txBox="1"/>
-          <p:nvPr/>
-        </p:nvSpPr>
-        <p:spPr>
-          <a:xfrm>
-            <a:off x="457200" y="1463040"/>
-            <a:ext cx="11247120" cy="4754880"/>
-          </a:xfrm>
-          <a:prstGeom prst="rect">
-            <a:avLst/>
-          </a:prstGeom>
-          <a:noFill/>
-        </p:spPr>
-        <p:txBody>
-          <a:bodyPr wrap="square">
-            <a:spAutoFit/>
-          </a:bodyPr>
-          <a:lstStyle/>
-          <a:p>
-            <a:pPr>
-              <a:spcAft>
-                <a:spcPts val="800"/>
-              </a:spcAft>
-              <a:defRPr sz="2000">
-                <a:solidFill>
-                  <a:srgbClr val="445577"/>
-                </a:solidFill>
-              </a:defRPr>
-            </a:pPr>
-            <a:r>
-              <a:t>• A4 = 440 Hz reference check.</a:t>
-            </a:r>
-          </a:p>
-          <a:p>
-            <a:pPr>
-              <a:spcAft>
-                <a:spcPts val="800"/>
-              </a:spcAft>
-              <a:defRPr sz="2000">
-                <a:solidFill>
-                  <a:srgbClr val="445577"/>
-                </a:solidFill>
-              </a:defRPr>
-            </a:pPr>
-            <a:r>
-              <a:t>• Tuning targets logged in validation.csv.</a:t>
-            </a:r>
-          </a:p>
-          <a:p>
-            <a:pPr>
-              <a:spcAft>
-                <a:spcPts val="800"/>
-              </a:spcAft>
-              <a:defRPr sz="2000">
-                <a:solidFill>
-                  <a:srgbClr val="445577"/>
-                </a:solidFill>
-              </a:defRPr>
-            </a:pPr>
-            <a:r>
-              <a:t>• Critical dimensions verified against design sheet and CAD.</a:t>
-            </a:r>
-          </a:p>
-          <a:p>
-            <a:pPr>
-              <a:spcAft>
-                <a:spcPts val="800"/>
-              </a:spcAft>
-              <a:defRPr sz="2000">
-                <a:solidFill>
-                  <a:srgbClr val="445577"/>
-                </a:solidFill>
-              </a:defRPr>
-            </a:pPr>
-            <a:r>
-              <a:t>• Photos and revision notes after each major step.</a:t>
-            </a:r>
-          </a:p>
-        </p:txBody>
-      </p:sp>
-      <p:sp>
-        <p:nvSpPr>
-          <p:cNvPr id="5" name="TextBox 4"/>
-          <p:cNvSpPr txBox="1"/>
-          <p:nvPr/>
-        </p:nvSpPr>
-        <p:spPr>
-          <a:xfrm>
-            <a:off x="457200" y="6446520"/>
-            <a:ext cx="11247120" cy="274320"/>
-          </a:xfrm>
-          <a:prstGeom prst="rect">
-            <a:avLst/>
-          </a:prstGeom>
-          <a:noFill/>
-        </p:spPr>
-        <p:txBody>
-          <a:bodyPr wrap="none">
-            <a:spAutoFit/>
-          </a:bodyPr>
-          <a:lstStyle/>
-          <a:p>
-            <a:pPr>
-              <a:defRPr sz="1000">
-                <a:solidFill>
-                  <a:srgbClr val="445577"/>
-                </a:solidFill>
-              </a:defRPr>
-            </a:pPr>
-            <a:r>
-              <a:t>Lyre Build Packet  |  Slide 11 of 13</a:t>
-            </a:r>
-          </a:p>
-        </p:txBody>
-      </p:sp>
-    </p:spTree>
-  </p:cSld>
-  <p:clrMapOvr>
-    <a:masterClrMapping/>
-  </p:clrMapOvr>
-</p:sld>
-</file>
-
-<file path=ppt/slides/slide12.xml><?xml version="1.0" encoding="utf-8"?>
-<p:sld xmlns:a="http://schemas.openxmlformats.org/drawingml/2006/main" xmlns:p="http://schemas.openxmlformats.org/presentationml/2006/main" xmlns:r="http://schemas.openxmlformats.org/officeDocument/2006/relationships">
-  <p:cSld>
-    <p:spTree>
-      <p:nvGrpSpPr>
-        <p:cNvPr id="1" name=""/>
-        <p:cNvGrpSpPr/>
-        <p:nvPr/>
-      </p:nvGrpSpPr>
-      <p:grpSpPr/>
-      <p:sp>
-        <p:nvSpPr>
-          <p:cNvPr id="2" name="Rectangle 1"/>
-          <p:cNvSpPr/>
-          <p:nvPr/>
-        </p:nvSpPr>
-        <p:spPr>
-          <a:xfrm>
-            <a:off x="0" y="0"/>
-            <a:ext cx="12191695" cy="411480"/>
-          </a:xfrm>
-          <a:prstGeom prst="rect">
-            <a:avLst/>
-          </a:prstGeom>
-          <a:solidFill>
-            <a:srgbClr val="1F3A68"/>
-          </a:solidFill>
-          <a:ln>
-            <a:noFill/>
-          </a:ln>
-        </p:spPr>
-        <p:style>
-          <a:lnRef idx="1">
-            <a:schemeClr val="accent1"/>
-          </a:lnRef>
-          <a:fillRef idx="3">
-            <a:schemeClr val="accent1"/>
-          </a:fillRef>
-          <a:effectRef idx="2">
-            <a:schemeClr val="accent1"/>
-          </a:effectRef>
-          <a:fontRef idx="minor">
-            <a:schemeClr val="lt1"/>
-          </a:fontRef>
-        </p:style>
-        <p:txBody>
-          <a:bodyPr rtlCol="0" anchor="ctr"/>
-          <a:lstStyle/>
-          <a:p>
-            <a:pPr algn="ctr"/>
-          </a:p>
-        </p:txBody>
-      </p:sp>
-      <p:sp>
-        <p:nvSpPr>
-          <p:cNvPr id="3" name="TextBox 2"/>
-          <p:cNvSpPr txBox="1"/>
-          <p:nvPr/>
-        </p:nvSpPr>
-        <p:spPr>
-          <a:xfrm>
-            <a:off x="457200" y="548640"/>
-            <a:ext cx="11247120" cy="914400"/>
-          </a:xfrm>
-          <a:prstGeom prst="rect">
-            <a:avLst/>
-          </a:prstGeom>
-          <a:noFill/>
-        </p:spPr>
-        <p:txBody>
-          <a:bodyPr wrap="square">
-            <a:spAutoFit/>
-          </a:bodyPr>
-          <a:lstStyle/>
-          <a:p>
-            <a:pPr>
-              <a:defRPr sz="3000" b="1">
-                <a:solidFill>
-                  <a:srgbClr val="1F3A68"/>
-                </a:solidFill>
-              </a:defRPr>
-            </a:pPr>
-            <a:r>
-              <a:t>Open Risks / Decisions</a:t>
-            </a:r>
-          </a:p>
-        </p:txBody>
-      </p:sp>
-      <p:sp>
-        <p:nvSpPr>
-          <p:cNvPr id="4" name="TextBox 3"/>
-          <p:cNvSpPr txBox="1"/>
-          <p:nvPr/>
-        </p:nvSpPr>
-        <p:spPr>
-          <a:xfrm>
-            <a:off x="457200" y="1463040"/>
-            <a:ext cx="11247120" cy="4754880"/>
-          </a:xfrm>
-          <a:prstGeom prst="rect">
-            <a:avLst/>
-          </a:prstGeom>
-          <a:noFill/>
-        </p:spPr>
-        <p:txBody>
-          <a:bodyPr wrap="square">
-            <a:spAutoFit/>
-          </a:bodyPr>
-          <a:lstStyle/>
-          <a:p>
-            <a:pPr>
-              <a:spcAft>
-                <a:spcPts val="800"/>
-              </a:spcAft>
-              <a:defRPr sz="2000">
-                <a:solidFill>
-                  <a:srgbClr val="445577"/>
-                </a:solidFill>
-              </a:defRPr>
-            </a:pPr>
-            <a:r>
-              <a:t>• TBDs in design sheet and BOM.</a:t>
-            </a:r>
-          </a:p>
-          <a:p>
-            <a:pPr>
-              <a:spcAft>
-                <a:spcPts val="800"/>
-              </a:spcAft>
-              <a:defRPr sz="2000">
-                <a:solidFill>
-                  <a:srgbClr val="445577"/>
-                </a:solidFill>
-              </a:defRPr>
-            </a:pPr>
-            <a:r>
-              <a:t>• Supplier price/availability not yet verified.</a:t>
-            </a:r>
-          </a:p>
-          <a:p>
-            <a:pPr>
-              <a:spcAft>
-                <a:spcPts val="800"/>
-              </a:spcAft>
-              <a:defRPr sz="2000">
-                <a:solidFill>
-                  <a:srgbClr val="445577"/>
-                </a:solidFill>
-              </a:defRPr>
-            </a:pPr>
-            <a:r>
-              <a:t>• Generated images marked as concept placeholders.</a:t>
-            </a:r>
-          </a:p>
-          <a:p>
-            <a:pPr>
-              <a:spcAft>
-                <a:spcPts val="800"/>
-              </a:spcAft>
-              <a:defRPr sz="2000">
-                <a:solidFill>
-                  <a:srgbClr val="445577"/>
-                </a:solidFill>
-              </a:defRPr>
-            </a:pPr>
-            <a:r>
-              <a:t>• Empirical corrections await measured prototype data.</a:t>
-            </a:r>
-          </a:p>
-        </p:txBody>
-      </p:sp>
-      <p:sp>
-        <p:nvSpPr>
-          <p:cNvPr id="5" name="TextBox 4"/>
-          <p:cNvSpPr txBox="1"/>
-          <p:nvPr/>
-        </p:nvSpPr>
-        <p:spPr>
-          <a:xfrm>
-            <a:off x="457200" y="6446520"/>
-            <a:ext cx="11247120" cy="274320"/>
-          </a:xfrm>
-          <a:prstGeom prst="rect">
-            <a:avLst/>
-          </a:prstGeom>
-          <a:noFill/>
-        </p:spPr>
-        <p:txBody>
-          <a:bodyPr wrap="none">
-            <a:spAutoFit/>
-          </a:bodyPr>
-          <a:lstStyle/>
-          <a:p>
-            <a:pPr>
-              <a:defRPr sz="1000">
-                <a:solidFill>
-                  <a:srgbClr val="445577"/>
-                </a:solidFill>
-              </a:defRPr>
-            </a:pPr>
-            <a:r>
-              <a:t>Lyre Build Packet  |  Slide 12 of 13</a:t>
-            </a:r>
-          </a:p>
-        </p:txBody>
-      </p:sp>
-    </p:spTree>
-  </p:cSld>
-  <p:clrMapOvr>
-    <a:masterClrMapping/>
-  </p:clrMapOvr>
-</p:sld>
-</file>
-
-<file path=ppt/slides/slide13.xml><?xml version="1.0" encoding="utf-8"?>
-<p:sld xmlns:a="http://schemas.openxmlformats.org/drawingml/2006/main" xmlns:p="http://schemas.openxmlformats.org/presentationml/2006/main" xmlns:r="http://schemas.openxmlformats.org/officeDocument/2006/relationships">
-  <p:cSld>
-    <p:spTree>
-      <p:nvGrpSpPr>
-        <p:cNvPr id="1" name=""/>
-        <p:cNvGrpSpPr/>
-        <p:nvPr/>
-      </p:nvGrpSpPr>
-      <p:grpSpPr/>
-      <p:sp>
-        <p:nvSpPr>
-          <p:cNvPr id="2" name="Rectangle 1"/>
-          <p:cNvSpPr/>
-          <p:nvPr/>
-        </p:nvSpPr>
-        <p:spPr>
-          <a:xfrm>
-            <a:off x="0" y="0"/>
-            <a:ext cx="12191695" cy="411480"/>
-          </a:xfrm>
-          <a:prstGeom prst="rect">
-            <a:avLst/>
-          </a:prstGeom>
-          <a:solidFill>
-            <a:srgbClr val="1F3A68"/>
-          </a:solidFill>
-          <a:ln>
-            <a:noFill/>
-          </a:ln>
-        </p:spPr>
-        <p:style>
-          <a:lnRef idx="1">
-            <a:schemeClr val="accent1"/>
-          </a:lnRef>
-          <a:fillRef idx="3">
-            <a:schemeClr val="accent1"/>
-          </a:fillRef>
-          <a:effectRef idx="2">
-            <a:schemeClr val="accent1"/>
-          </a:effectRef>
-          <a:fontRef idx="minor">
-            <a:schemeClr val="lt1"/>
-          </a:fontRef>
-        </p:style>
-        <p:txBody>
-          <a:bodyPr rtlCol="0" anchor="ctr"/>
-          <a:lstStyle/>
-          <a:p>
-            <a:pPr algn="ctr"/>
-          </a:p>
-        </p:txBody>
-      </p:sp>
-      <p:sp>
-        <p:nvSpPr>
-          <p:cNvPr id="3" name="TextBox 2"/>
-          <p:cNvSpPr txBox="1"/>
-          <p:nvPr/>
-        </p:nvSpPr>
-        <p:spPr>
-          <a:xfrm>
-            <a:off x="457200" y="548640"/>
-            <a:ext cx="11247120" cy="914400"/>
-          </a:xfrm>
-          <a:prstGeom prst="rect">
-            <a:avLst/>
-          </a:prstGeom>
-          <a:noFill/>
-        </p:spPr>
-        <p:txBody>
-          <a:bodyPr wrap="square">
-            <a:spAutoFit/>
-          </a:bodyPr>
-          <a:lstStyle/>
-          <a:p>
-            <a:pPr>
-              <a:defRPr sz="3000" b="1">
-                <a:solidFill>
-                  <a:srgbClr val="1F3A68"/>
-                </a:solidFill>
-              </a:defRPr>
-            </a:pPr>
-            <a:r>
-              <a:t>Next Actions</a:t>
-            </a:r>
-          </a:p>
-        </p:txBody>
-      </p:sp>
-      <p:sp>
-        <p:nvSpPr>
-          <p:cNvPr id="4" name="TextBox 3"/>
-          <p:cNvSpPr txBox="1"/>
-          <p:nvPr/>
-        </p:nvSpPr>
-        <p:spPr>
-          <a:xfrm>
-            <a:off x="457200" y="1463040"/>
-            <a:ext cx="11247120" cy="4754880"/>
-          </a:xfrm>
-          <a:prstGeom prst="rect">
-            <a:avLst/>
-          </a:prstGeom>
-          <a:noFill/>
-        </p:spPr>
-        <p:txBody>
-          <a:bodyPr wrap="square">
-            <a:spAutoFit/>
-          </a:bodyPr>
-          <a:lstStyle/>
-          <a:p>
-            <a:pPr>
-              <a:spcAft>
-                <a:spcPts val="800"/>
-              </a:spcAft>
-              <a:defRPr sz="2000">
-                <a:solidFill>
-                  <a:srgbClr val="445577"/>
-                </a:solidFill>
-              </a:defRPr>
-            </a:pPr>
-            <a:r>
-              <a:t>• Replace TBDs with measured/source-backed values.</a:t>
-            </a:r>
-          </a:p>
-          <a:p>
-            <a:pPr>
-              <a:spcAft>
-                <a:spcPts val="800"/>
-              </a:spcAft>
-              <a:defRPr sz="2000">
-                <a:solidFill>
-                  <a:srgbClr val="445577"/>
-                </a:solidFill>
-              </a:defRPr>
-            </a:pPr>
-            <a:r>
-              <a:t>• Verify live supplier price and availability before buying.</a:t>
-            </a:r>
-          </a:p>
-          <a:p>
-            <a:pPr>
-              <a:spcAft>
-                <a:spcPts val="800"/>
-              </a:spcAft>
-              <a:defRPr sz="2000">
-                <a:solidFill>
-                  <a:srgbClr val="445577"/>
-                </a:solidFill>
-              </a:defRPr>
-            </a:pPr>
-            <a:r>
-              <a:t>• Export final drawings and visual BOM images.</a:t>
-            </a:r>
-          </a:p>
-          <a:p>
-            <a:pPr>
-              <a:spcAft>
-                <a:spcPts val="800"/>
-              </a:spcAft>
-              <a:defRPr sz="2000">
-                <a:solidFill>
-                  <a:srgbClr val="445577"/>
-                </a:solidFill>
-              </a:defRPr>
-            </a:pPr>
-            <a:r>
-              <a:t>• Regenerate this deck and print packet after final edits.</a:t>
-            </a:r>
-          </a:p>
-        </p:txBody>
-      </p:sp>
-      <p:sp>
-        <p:nvSpPr>
-          <p:cNvPr id="5" name="TextBox 4"/>
-          <p:cNvSpPr txBox="1"/>
-          <p:nvPr/>
-        </p:nvSpPr>
-        <p:spPr>
-          <a:xfrm>
-            <a:off x="457200" y="6446520"/>
-            <a:ext cx="11247120" cy="274320"/>
-          </a:xfrm>
-          <a:prstGeom prst="rect">
-            <a:avLst/>
-          </a:prstGeom>
-          <a:noFill/>
-        </p:spPr>
-        <p:txBody>
-          <a:bodyPr wrap="none">
-            <a:spAutoFit/>
-          </a:bodyPr>
-          <a:lstStyle/>
-          <a:p>
-            <a:pPr>
-              <a:defRPr sz="1000">
-                <a:solidFill>
-                  <a:srgbClr val="445577"/>
-                </a:solidFill>
-              </a:defRPr>
-            </a:pPr>
-            <a:r>
-              <a:t>Lyre Build Packet  |  Slide 13 of 13</a:t>
+              <a:t>No build-ready or measured claims yet</a:t>
             </a:r>
           </a:p>
         </p:txBody>
@@ -4112,163 +3173,61 @@
       <p:grpSpPr/>
       <p:sp>
         <p:nvSpPr>
-          <p:cNvPr id="2" name="Rectangle 1"/>
-          <p:cNvSpPr/>
-          <p:nvPr/>
-        </p:nvSpPr>
-        <p:spPr>
-          <a:xfrm>
-            <a:off x="0" y="0"/>
-            <a:ext cx="12191695" cy="411480"/>
-          </a:xfrm>
-          <a:prstGeom prst="rect">
-            <a:avLst/>
-          </a:prstGeom>
-          <a:solidFill>
-            <a:srgbClr val="1F3A68"/>
-          </a:solidFill>
-          <a:ln>
-            <a:noFill/>
-          </a:ln>
-        </p:spPr>
-        <p:style>
-          <a:lnRef idx="1">
-            <a:schemeClr val="accent1"/>
-          </a:lnRef>
-          <a:fillRef idx="3">
-            <a:schemeClr val="accent1"/>
-          </a:fillRef>
-          <a:effectRef idx="2">
-            <a:schemeClr val="accent1"/>
-          </a:effectRef>
-          <a:fontRef idx="minor">
-            <a:schemeClr val="lt1"/>
-          </a:fontRef>
-        </p:style>
-        <p:txBody>
-          <a:bodyPr rtlCol="0" anchor="ctr"/>
-          <a:lstStyle/>
-          <a:p>
-            <a:pPr algn="ctr"/>
-          </a:p>
-        </p:txBody>
-      </p:sp>
-      <p:sp>
-        <p:nvSpPr>
-          <p:cNvPr id="3" name="TextBox 2"/>
-          <p:cNvSpPr txBox="1"/>
-          <p:nvPr/>
-        </p:nvSpPr>
-        <p:spPr>
-          <a:xfrm>
-            <a:off x="457200" y="548640"/>
-            <a:ext cx="11247120" cy="914400"/>
-          </a:xfrm>
-          <a:prstGeom prst="rect">
-            <a:avLst/>
-          </a:prstGeom>
-          <a:noFill/>
-        </p:spPr>
-        <p:txBody>
-          <a:bodyPr wrap="square">
-            <a:spAutoFit/>
-          </a:bodyPr>
+          <p:cNvPr id="2" name="Title 1"/>
+          <p:cNvSpPr>
+            <a:spLocks noGrp="1"/>
+          </p:cNvSpPr>
+          <p:nvPr>
+            <p:ph type="title"/>
+          </p:nvPr>
+        </p:nvSpPr>
+        <p:spPr/>
+        <p:txBody>
+          <a:bodyPr/>
+          <a:lstStyle/>
+          <a:p>
+            <a:r>
+              <a:t>Readiness Boundary</a:t>
+            </a:r>
+          </a:p>
+        </p:txBody>
+      </p:sp>
+      <p:sp>
+        <p:nvSpPr>
+          <p:cNvPr id="3" name="Content Placeholder 2"/>
+          <p:cNvSpPr>
+            <a:spLocks noGrp="1"/>
+          </p:cNvSpPr>
+          <p:nvPr>
+            <p:ph idx="1"/>
+          </p:nvPr>
+        </p:nvSpPr>
+        <p:spPr/>
+        <p:txBody>
+          <a:bodyPr/>
           <a:lstStyle/>
           <a:p>
             <a:pPr>
-              <a:defRPr sz="3000" b="1">
-                <a:solidFill>
-                  <a:srgbClr val="1F3A68"/>
-                </a:solidFill>
-              </a:defRPr>
+              <a:defRPr sz="2000"/>
             </a:pPr>
             <a:r>
-              <a:t>Project Intent</a:t>
-            </a:r>
-          </a:p>
-        </p:txBody>
-      </p:sp>
-      <p:sp>
-        <p:nvSpPr>
-          <p:cNvPr id="4" name="TextBox 3"/>
-          <p:cNvSpPr txBox="1"/>
-          <p:nvPr/>
-        </p:nvSpPr>
-        <p:spPr>
-          <a:xfrm>
-            <a:off x="457200" y="1463040"/>
-            <a:ext cx="11247120" cy="4754880"/>
-          </a:xfrm>
-          <a:prstGeom prst="rect">
-            <a:avLst/>
-          </a:prstGeom>
-          <a:noFill/>
-        </p:spPr>
-        <p:txBody>
-          <a:bodyPr wrap="square">
-            <a:spAutoFit/>
-          </a:bodyPr>
-          <a:lstStyle/>
+              <a:t>String gauges, tension, percent breaking, and load path remain measurement-required</a:t>
+            </a:r>
+          </a:p>
           <a:p>
             <a:pPr>
-              <a:spcAft>
-                <a:spcPts val="800"/>
-              </a:spcAft>
-              <a:defRPr sz="2000">
-                <a:solidFill>
-                  <a:srgbClr val="445577"/>
-                </a:solidFill>
-              </a:defRPr>
+              <a:defRPr sz="2000"/>
             </a:pPr>
             <a:r>
-              <a:t>• Create a small bench-buildable lyre packet that can move from concept to a</a:t>
-            </a:r>
-            <a:br/>
-            <a:r>
-              <a:t>first shop prototype without hiding the important string-load unknowns. The</a:t>
-            </a:r>
-            <a:br/>
-            <a:r>
-              <a:t>baseline is a compact 10-string plucked instrument with a flat soundboard,</a:t>
-            </a:r>
-            <a:br/>
-            <a:r>
-              <a:t>two arms, a crossbar/yoke, and individual tuning pins.</a:t>
-            </a:r>
-          </a:p>
-        </p:txBody>
-      </p:sp>
-      <p:sp>
-        <p:nvSpPr>
-          <p:cNvPr id="5" name="TextBox 4"/>
-          <p:cNvSpPr txBox="1"/>
-          <p:nvPr/>
-        </p:nvSpPr>
-        <p:spPr>
-          <a:xfrm>
-            <a:off x="457200" y="6446520"/>
-            <a:ext cx="11247120" cy="274320"/>
-          </a:xfrm>
-          <a:prstGeom prst="rect">
-            <a:avLst/>
-          </a:prstGeom>
-          <a:noFill/>
-        </p:spPr>
-        <p:txBody>
-          <a:bodyPr wrap="none">
-            <a:spAutoFit/>
-          </a:bodyPr>
-          <a:lstStyle/>
+              <a:t>CAD/drawings are starter notes only</a:t>
+            </a:r>
+          </a:p>
           <a:p>
             <a:pPr>
-              <a:defRPr sz="1000">
-                <a:solidFill>
-                  <a:srgbClr val="445577"/>
-                </a:solidFill>
-              </a:defRPr>
+              <a:defRPr sz="2000"/>
             </a:pPr>
             <a:r>
-              <a:t>Lyre Build Packet  |  Slide 2 of 13</a:t>
+              <a:t>Visual outputs are reference/review surfaces, not fabrication authority</a:t>
             </a:r>
           </a:p>
         </p:txBody>
@@ -4293,171 +3252,61 @@
       <p:grpSpPr/>
       <p:sp>
         <p:nvSpPr>
-          <p:cNvPr id="2" name="Rectangle 1"/>
-          <p:cNvSpPr/>
-          <p:nvPr/>
-        </p:nvSpPr>
-        <p:spPr>
-          <a:xfrm>
-            <a:off x="0" y="0"/>
-            <a:ext cx="12191695" cy="411480"/>
-          </a:xfrm>
-          <a:prstGeom prst="rect">
-            <a:avLst/>
-          </a:prstGeom>
-          <a:solidFill>
-            <a:srgbClr val="1F3A68"/>
-          </a:solidFill>
-          <a:ln>
-            <a:noFill/>
-          </a:ln>
-        </p:spPr>
-        <p:style>
-          <a:lnRef idx="1">
-            <a:schemeClr val="accent1"/>
-          </a:lnRef>
-          <a:fillRef idx="3">
-            <a:schemeClr val="accent1"/>
-          </a:fillRef>
-          <a:effectRef idx="2">
-            <a:schemeClr val="accent1"/>
-          </a:effectRef>
-          <a:fontRef idx="minor">
-            <a:schemeClr val="lt1"/>
-          </a:fontRef>
-        </p:style>
-        <p:txBody>
-          <a:bodyPr rtlCol="0" anchor="ctr"/>
-          <a:lstStyle/>
-          <a:p>
-            <a:pPr algn="ctr"/>
-          </a:p>
-        </p:txBody>
-      </p:sp>
-      <p:sp>
-        <p:nvSpPr>
-          <p:cNvPr id="3" name="TextBox 2"/>
-          <p:cNvSpPr txBox="1"/>
-          <p:nvPr/>
-        </p:nvSpPr>
-        <p:spPr>
-          <a:xfrm>
-            <a:off x="457200" y="548640"/>
-            <a:ext cx="11247120" cy="914400"/>
-          </a:xfrm>
-          <a:prstGeom prst="rect">
-            <a:avLst/>
-          </a:prstGeom>
-          <a:noFill/>
-        </p:spPr>
-        <p:txBody>
-          <a:bodyPr wrap="square">
-            <a:spAutoFit/>
-          </a:bodyPr>
+          <p:cNvPr id="2" name="Title 1"/>
+          <p:cNvSpPr>
+            <a:spLocks noGrp="1"/>
+          </p:cNvSpPr>
+          <p:nvPr>
+            <p:ph type="title"/>
+          </p:nvPr>
+        </p:nvSpPr>
+        <p:spPr/>
+        <p:txBody>
+          <a:bodyPr/>
+          <a:lstStyle/>
+          <a:p>
+            <a:r>
+              <a:t>New Evidence Gates</a:t>
+            </a:r>
+          </a:p>
+        </p:txBody>
+      </p:sp>
+      <p:sp>
+        <p:nvSpPr>
+          <p:cNvPr id="3" name="Content Placeholder 2"/>
+          <p:cNvSpPr>
+            <a:spLocks noGrp="1"/>
+          </p:cNvSpPr>
+          <p:nvPr>
+            <p:ph idx="1"/>
+          </p:nvPr>
+        </p:nvSpPr>
+        <p:spPr/>
+        <p:txBody>
+          <a:bodyPr/>
           <a:lstStyle/>
           <a:p>
             <a:pPr>
-              <a:defRPr sz="3000" b="1">
-                <a:solidFill>
-                  <a:srgbClr val="1F3A68"/>
-                </a:solidFill>
-              </a:defRPr>
+              <a:defRPr sz="2000"/>
             </a:pPr>
             <a:r>
-              <a:t>Physics Model</a:t>
-            </a:r>
-          </a:p>
-        </p:txBody>
-      </p:sp>
-      <p:sp>
-        <p:nvSpPr>
-          <p:cNvPr id="4" name="TextBox 3"/>
-          <p:cNvSpPr txBox="1"/>
-          <p:nvPr/>
-        </p:nvSpPr>
-        <p:spPr>
-          <a:xfrm>
-            <a:off x="457200" y="1463040"/>
-            <a:ext cx="11247120" cy="4754880"/>
-          </a:xfrm>
-          <a:prstGeom prst="rect">
-            <a:avLst/>
-          </a:prstGeom>
-          <a:noFill/>
-        </p:spPr>
-        <p:txBody>
-          <a:bodyPr wrap="square">
-            <a:spAutoFit/>
-          </a:bodyPr>
-          <a:lstStyle/>
+              <a:t>string-schedule.csv for C4-E5 targets and unresolved tension fields</a:t>
+            </a:r>
+          </a:p>
           <a:p>
             <a:pPr>
-              <a:spcAft>
-                <a:spcPts val="800"/>
-              </a:spcAft>
-              <a:defRPr sz="2000">
-                <a:solidFill>
-                  <a:srgbClr val="445577"/>
-                </a:solidFill>
-              </a:defRPr>
+              <a:defRPr sz="2000"/>
             </a:pPr>
             <a:r>
-              <a:t>• Strings use the Mersenne-Taylor relationship:</a:t>
+              <a:t>bridge-soundboard-load-register.csv for bridge, soundboard, yoke, pins, and joinery</a:t>
             </a:r>
           </a:p>
           <a:p>
             <a:pPr>
-              <a:spcAft>
-                <a:spcPts val="1000"/>
-              </a:spcAft>
-              <a:defRPr sz="1600">
-                <a:solidFill>
-                  <a:srgbClr val="1F3A68"/>
-                </a:solidFill>
-                <a:latin typeface="Consolas"/>
-              </a:defRPr>
+              <a:defRPr sz="2000"/>
             </a:pPr>
             <a:r>
-              <a:t>f = (1 / (2 L)) * sqrt(T / mu)</a:t>
-            </a:r>
-            <a:br/>
-            <a:r>
-              <a:t>mu = density * pi * (diameter / 2)^2</a:t>
-            </a:r>
-          </a:p>
-        </p:txBody>
-      </p:sp>
-      <p:sp>
-        <p:nvSpPr>
-          <p:cNvPr id="5" name="TextBox 4"/>
-          <p:cNvSpPr txBox="1"/>
-          <p:nvPr/>
-        </p:nvSpPr>
-        <p:spPr>
-          <a:xfrm>
-            <a:off x="457200" y="6446520"/>
-            <a:ext cx="11247120" cy="274320"/>
-          </a:xfrm>
-          <a:prstGeom prst="rect">
-            <a:avLst/>
-          </a:prstGeom>
-          <a:noFill/>
-        </p:spPr>
-        <p:txBody>
-          <a:bodyPr wrap="none">
-            <a:spAutoFit/>
-          </a:bodyPr>
-          <a:lstStyle/>
-          <a:p>
-            <a:pPr>
-              <a:defRPr sz="1000">
-                <a:solidFill>
-                  <a:srgbClr val="445577"/>
-                </a:solidFill>
-              </a:defRPr>
-            </a:pPr>
-            <a:r>
-              <a:t>Lyre Build Packet  |  Slide 3 of 13</a:t>
+              <a:t>visual-output-register.csv for non-authoritative images and exports</a:t>
             </a:r>
           </a:p>
         </p:txBody>
@@ -4482,196 +3331,69 @@
       <p:grpSpPr/>
       <p:sp>
         <p:nvSpPr>
-          <p:cNvPr id="2" name="Rectangle 1"/>
-          <p:cNvSpPr/>
-          <p:nvPr/>
-        </p:nvSpPr>
-        <p:spPr>
-          <a:xfrm>
-            <a:off x="0" y="0"/>
-            <a:ext cx="12191695" cy="411480"/>
-          </a:xfrm>
-          <a:prstGeom prst="rect">
-            <a:avLst/>
-          </a:prstGeom>
-          <a:solidFill>
-            <a:srgbClr val="1F3A68"/>
-          </a:solidFill>
-          <a:ln>
-            <a:noFill/>
-          </a:ln>
-        </p:spPr>
-        <p:style>
-          <a:lnRef idx="1">
-            <a:schemeClr val="accent1"/>
-          </a:lnRef>
-          <a:fillRef idx="3">
-            <a:schemeClr val="accent1"/>
-          </a:fillRef>
-          <a:effectRef idx="2">
-            <a:schemeClr val="accent1"/>
-          </a:effectRef>
-          <a:fontRef idx="minor">
-            <a:schemeClr val="lt1"/>
-          </a:fontRef>
-        </p:style>
-        <p:txBody>
-          <a:bodyPr rtlCol="0" anchor="ctr"/>
-          <a:lstStyle/>
-          <a:p>
-            <a:pPr algn="ctr"/>
-          </a:p>
-        </p:txBody>
-      </p:sp>
-      <p:sp>
-        <p:nvSpPr>
-          <p:cNvPr id="3" name="TextBox 2"/>
-          <p:cNvSpPr txBox="1"/>
-          <p:nvPr/>
-        </p:nvSpPr>
-        <p:spPr>
-          <a:xfrm>
-            <a:off x="457200" y="548640"/>
-            <a:ext cx="11247120" cy="914400"/>
-          </a:xfrm>
-          <a:prstGeom prst="rect">
-            <a:avLst/>
-          </a:prstGeom>
-          <a:noFill/>
-        </p:spPr>
-        <p:txBody>
-          <a:bodyPr wrap="square">
-            <a:spAutoFit/>
-          </a:bodyPr>
+          <p:cNvPr id="2" name="Title 1"/>
+          <p:cNvSpPr>
+            <a:spLocks noGrp="1"/>
+          </p:cNvSpPr>
+          <p:nvPr>
+            <p:ph type="title"/>
+          </p:nvPr>
+        </p:nvSpPr>
+        <p:spPr/>
+        <p:txBody>
+          <a:bodyPr/>
+          <a:lstStyle/>
+          <a:p>
+            <a:r>
+              <a:t>Validation</a:t>
+            </a:r>
+          </a:p>
+        </p:txBody>
+      </p:sp>
+      <p:sp>
+        <p:nvSpPr>
+          <p:cNvPr id="3" name="Content Placeholder 2"/>
+          <p:cNvSpPr>
+            <a:spLocks noGrp="1"/>
+          </p:cNvSpPr>
+          <p:nvPr>
+            <p:ph idx="1"/>
+          </p:nvPr>
+        </p:nvSpPr>
+        <p:spPr/>
+        <p:txBody>
+          <a:bodyPr/>
           <a:lstStyle/>
           <a:p>
             <a:pPr>
-              <a:defRPr sz="3000" b="1">
-                <a:solidFill>
-                  <a:srgbClr val="1F3A68"/>
-                </a:solidFill>
-              </a:defRPr>
+              <a:defRPr sz="2000"/>
             </a:pPr>
             <a:r>
-              <a:t>How To Use This Packet</a:t>
-            </a:r>
-          </a:p>
-        </p:txBody>
-      </p:sp>
-      <p:sp>
-        <p:nvSpPr>
-          <p:cNvPr id="4" name="TextBox 3"/>
-          <p:cNvSpPr txBox="1"/>
-          <p:nvPr/>
-        </p:nvSpPr>
-        <p:spPr>
-          <a:xfrm>
-            <a:off x="457200" y="1463040"/>
-            <a:ext cx="11247120" cy="4754880"/>
-          </a:xfrm>
-          <a:prstGeom prst="rect">
-            <a:avLst/>
-          </a:prstGeom>
-          <a:noFill/>
-        </p:spPr>
-        <p:txBody>
-          <a:bodyPr wrap="square">
-            <a:spAutoFit/>
-          </a:bodyPr>
-          <a:lstStyle/>
+              <a:t>Pitch-up after selected string schedule</a:t>
+            </a:r>
+          </a:p>
           <a:p>
             <a:pPr>
-              <a:spcAft>
-                <a:spcPts val="800"/>
-              </a:spcAft>
-              <a:defRPr sz="2000">
-                <a:solidFill>
-                  <a:srgbClr val="445577"/>
-                </a:solidFill>
-              </a:defRPr>
+              <a:defRPr sz="2000"/>
             </a:pPr>
             <a:r>
-              <a:t>• Start with design.md for intent and assumptions.</a:t>
+              <a:t>Scrap-block tuning pin torque and creep test</a:t>
             </a:r>
           </a:p>
           <a:p>
             <a:pPr>
-              <a:spcAft>
-                <a:spcPts val="800"/>
-              </a:spcAft>
-              <a:defRPr sz="2000">
-                <a:solidFill>
-                  <a:srgbClr val="445577"/>
-                </a:solidFill>
-              </a:defRPr>
+              <a:defRPr sz="2000"/>
             </a:pPr>
             <a:r>
-              <a:t>• Use bom.csv, sourcing.csv, and cut-list.csv before buying or cutting.</a:t>
+              <a:t>Soundboard deflection at no load, half tension, full tension, and 24 hours</a:t>
             </a:r>
           </a:p>
           <a:p>
             <a:pPr>
-              <a:spcAft>
-                <a:spcPts val="800"/>
-              </a:spcAft>
-              <a:defRPr sz="2000">
-                <a:solidFill>
-                  <a:srgbClr val="445577"/>
-                </a:solidFill>
-              </a:defRPr>
+              <a:defRPr sz="2000"/>
             </a:pPr>
             <a:r>
-              <a:t>• Use drawing-brief.md and CAD/CNC folders before machining.</a:t>
-            </a:r>
-          </a:p>
-          <a:p>
-            <a:pPr>
-              <a:spcAft>
-                <a:spcPts val="800"/>
-              </a:spcAft>
-              <a:defRPr sz="2000">
-                <a:solidFill>
-                  <a:srgbClr val="445577"/>
-                </a:solidFill>
-              </a:defRPr>
-            </a:pPr>
-            <a:r>
-              <a:t>• Print the packet for shopping, shop work, and validation.</a:t>
-            </a:r>
-          </a:p>
-        </p:txBody>
-      </p:sp>
-      <p:sp>
-        <p:nvSpPr>
-          <p:cNvPr id="5" name="TextBox 4"/>
-          <p:cNvSpPr txBox="1"/>
-          <p:nvPr/>
-        </p:nvSpPr>
-        <p:spPr>
-          <a:xfrm>
-            <a:off x="457200" y="6446520"/>
-            <a:ext cx="11247120" cy="274320"/>
-          </a:xfrm>
-          <a:prstGeom prst="rect">
-            <a:avLst/>
-          </a:prstGeom>
-          <a:noFill/>
-        </p:spPr>
-        <p:txBody>
-          <a:bodyPr wrap="none">
-            <a:spAutoFit/>
-          </a:bodyPr>
-          <a:lstStyle/>
-          <a:p>
-            <a:pPr>
-              <a:defRPr sz="1000">
-                <a:solidFill>
-                  <a:srgbClr val="445577"/>
-                </a:solidFill>
-              </a:defRPr>
-            </a:pPr>
-            <a:r>
-              <a:t>Lyre Build Packet  |  Slide 4 of 13</a:t>
+              <a:t>Full-size drawing or CAD detail before final frame cutting</a:t>
             </a:r>
           </a:p>
         </p:txBody>
@@ -4696,1082 +3418,61 @@
       <p:grpSpPr/>
       <p:sp>
         <p:nvSpPr>
-          <p:cNvPr id="2" name="Rectangle 1"/>
-          <p:cNvSpPr/>
-          <p:nvPr/>
-        </p:nvSpPr>
-        <p:spPr>
-          <a:xfrm>
-            <a:off x="0" y="0"/>
-            <a:ext cx="12191695" cy="411480"/>
-          </a:xfrm>
-          <a:prstGeom prst="rect">
-            <a:avLst/>
-          </a:prstGeom>
-          <a:solidFill>
-            <a:srgbClr val="1F3A68"/>
-          </a:solidFill>
-          <a:ln>
-            <a:noFill/>
-          </a:ln>
-        </p:spPr>
-        <p:style>
-          <a:lnRef idx="1">
-            <a:schemeClr val="accent1"/>
-          </a:lnRef>
-          <a:fillRef idx="3">
-            <a:schemeClr val="accent1"/>
-          </a:fillRef>
-          <a:effectRef idx="2">
-            <a:schemeClr val="accent1"/>
-          </a:effectRef>
-          <a:fontRef idx="minor">
-            <a:schemeClr val="lt1"/>
-          </a:fontRef>
-        </p:style>
-        <p:txBody>
-          <a:bodyPr rtlCol="0" anchor="ctr"/>
-          <a:lstStyle/>
-          <a:p>
-            <a:pPr algn="ctr"/>
-          </a:p>
-        </p:txBody>
-      </p:sp>
-      <p:sp>
-        <p:nvSpPr>
-          <p:cNvPr id="3" name="TextBox 2"/>
-          <p:cNvSpPr txBox="1"/>
-          <p:nvPr/>
-        </p:nvSpPr>
-        <p:spPr>
-          <a:xfrm>
-            <a:off x="457200" y="548640"/>
-            <a:ext cx="11247120" cy="914400"/>
-          </a:xfrm>
-          <a:prstGeom prst="rect">
-            <a:avLst/>
-          </a:prstGeom>
-          <a:noFill/>
-        </p:spPr>
-        <p:txBody>
-          <a:bodyPr wrap="square">
-            <a:spAutoFit/>
-          </a:bodyPr>
+          <p:cNvPr id="2" name="Title 1"/>
+          <p:cNvSpPr>
+            <a:spLocks noGrp="1"/>
+          </p:cNvSpPr>
+          <p:nvPr>
+            <p:ph type="title"/>
+          </p:nvPr>
+        </p:nvSpPr>
+        <p:spPr/>
+        <p:txBody>
+          <a:bodyPr/>
+          <a:lstStyle/>
+          <a:p>
+            <a:r>
+              <a:t>Next Actions</a:t>
+            </a:r>
+          </a:p>
+        </p:txBody>
+      </p:sp>
+      <p:sp>
+        <p:nvSpPr>
+          <p:cNvPr id="3" name="Content Placeholder 2"/>
+          <p:cNvSpPr>
+            <a:spLocks noGrp="1"/>
+          </p:cNvSpPr>
+          <p:nvPr>
+            <p:ph idx="1"/>
+          </p:nvPr>
+        </p:nvSpPr>
+        <p:spPr/>
+        <p:txBody>
+          <a:bodyPr/>
           <a:lstStyle/>
           <a:p>
             <a:pPr>
-              <a:defRPr sz="3000" b="1">
-                <a:solidFill>
-                  <a:srgbClr val="1F3A68"/>
-                </a:solidFill>
-              </a:defRPr>
+              <a:defRPr sz="2000"/>
             </a:pPr>
             <a:r>
-              <a:t>File Map</a:t>
-            </a:r>
-          </a:p>
-        </p:txBody>
-      </p:sp>
-      <p:sp>
-        <p:nvSpPr>
-          <p:cNvPr id="4" name="TextBox 3"/>
-          <p:cNvSpPr txBox="1"/>
-          <p:nvPr/>
-        </p:nvSpPr>
-        <p:spPr>
-          <a:xfrm>
-            <a:off x="457200" y="1463040"/>
-            <a:ext cx="11247120" cy="4754880"/>
-          </a:xfrm>
-          <a:prstGeom prst="rect">
-            <a:avLst/>
-          </a:prstGeom>
-          <a:noFill/>
-        </p:spPr>
-        <p:txBody>
-          <a:bodyPr wrap="square">
-            <a:spAutoFit/>
-          </a:bodyPr>
-          <a:lstStyle/>
+              <a:t>Resolve string stock from supplier or measured samples</a:t>
+            </a:r>
+          </a:p>
           <a:p>
             <a:pPr>
-              <a:spcAft>
-                <a:spcPts val="800"/>
-              </a:spcAft>
-              <a:defRPr sz="2000">
-                <a:solidFill>
-                  <a:srgbClr val="445577"/>
-                </a:solidFill>
-              </a:defRPr>
+              <a:defRPr sz="2000"/>
             </a:pPr>
             <a:r>
-              <a:t>• design.md: Project intent, catalog metadata, assumptions, and validation plan.</a:t>
+              <a:t>Review load path and pin edge distance</a:t>
             </a:r>
           </a:p>
           <a:p>
             <a:pPr>
-              <a:spcAft>
-                <a:spcPts val="800"/>
-              </a:spcAft>
-              <a:defRPr sz="2000">
-                <a:solidFill>
-                  <a:srgbClr val="445577"/>
-                </a:solidFill>
-              </a:defRPr>
+              <a:defRPr sz="2000"/>
             </a:pPr>
             <a:r>
-              <a:t>• bom.csv: Starter bill of materials with part categories, quantities, drawing refs, and notes.</a:t>
-            </a:r>
-          </a:p>
-          <a:p>
-            <a:pPr>
-              <a:spcAft>
-                <a:spcPts val="800"/>
-              </a:spcAft>
-              <a:defRPr sz="2000">
-                <a:solidFill>
-                  <a:srgbClr val="445577"/>
-                </a:solidFill>
-              </a:defRPr>
-            </a:pPr>
-            <a:r>
-              <a:t>• sourcing.csv: Supplier/search tracker with specs, price/date fields, lead time, substitutes, and risks.</a:t>
-            </a:r>
-          </a:p>
-          <a:p>
-            <a:pPr>
-              <a:spcAft>
-                <a:spcPts val="800"/>
-              </a:spcAft>
-              <a:defRPr sz="2000">
-                <a:solidFill>
-                  <a:srgbClr val="445577"/>
-                </a:solidFill>
-              </a:defRPr>
-            </a:pPr>
-            <a:r>
-              <a:t>• cut-list.csv: Rough/final stock sizes, material, grain/orientation, operations, yield, and offcuts.</a:t>
-            </a:r>
-          </a:p>
-          <a:p>
-            <a:pPr>
-              <a:spcAft>
-                <a:spcPts val="800"/>
-              </a:spcAft>
-              <a:defRPr sz="2000">
-                <a:solidFill>
-                  <a:srgbClr val="445577"/>
-                </a:solidFill>
-              </a:defRPr>
-            </a:pPr>
-            <a:r>
-              <a:t>• drawing-brief.md: Manufacturing drawing and technical product sketch brief.</a:t>
-            </a:r>
-          </a:p>
-          <a:p>
-            <a:pPr>
-              <a:spcAft>
-                <a:spcPts val="800"/>
-              </a:spcAft>
-              <a:defRPr sz="2000">
-                <a:solidFill>
-                  <a:srgbClr val="445577"/>
-                </a:solidFill>
-              </a:defRPr>
-            </a:pPr>
-            <a:r>
-              <a:t>• assembly-manual.md: Shop-facing sequence, tools, fixtures, safety, tuning, finishing, and maintenance notes.</a:t>
-            </a:r>
-          </a:p>
-          <a:p>
-            <a:pPr>
-              <a:spcAft>
-                <a:spcPts val="800"/>
-              </a:spcAft>
-              <a:defRPr sz="2000">
-                <a:solidFill>
-                  <a:srgbClr val="445577"/>
-                </a:solidFill>
-              </a:defRPr>
-            </a:pPr>
-            <a:r>
-              <a:t>• validation.csv: Target/measured values, tolerance, environment, result, and tuning/build action log.</a:t>
-            </a:r>
-          </a:p>
-          <a:p>
-            <a:pPr>
-              <a:spcAft>
-                <a:spcPts val="800"/>
-              </a:spcAft>
-              <a:defRPr sz="2000">
-                <a:solidFill>
-                  <a:srgbClr val="445577"/>
-                </a:solidFill>
-              </a:defRPr>
-            </a:pPr>
-            <a:r>
-              <a:t>• supplier-rfq.md: Supplier email/request-for-quote starter.</a:t>
-            </a:r>
-          </a:p>
-        </p:txBody>
-      </p:sp>
-      <p:sp>
-        <p:nvSpPr>
-          <p:cNvPr id="5" name="TextBox 4"/>
-          <p:cNvSpPr txBox="1"/>
-          <p:nvPr/>
-        </p:nvSpPr>
-        <p:spPr>
-          <a:xfrm>
-            <a:off x="457200" y="6446520"/>
-            <a:ext cx="11247120" cy="274320"/>
-          </a:xfrm>
-          <a:prstGeom prst="rect">
-            <a:avLst/>
-          </a:prstGeom>
-          <a:noFill/>
-        </p:spPr>
-        <p:txBody>
-          <a:bodyPr wrap="none">
-            <a:spAutoFit/>
-          </a:bodyPr>
-          <a:lstStyle/>
-          <a:p>
-            <a:pPr>
-              <a:defRPr sz="1000">
-                <a:solidFill>
-                  <a:srgbClr val="445577"/>
-                </a:solidFill>
-              </a:defRPr>
-            </a:pPr>
-            <a:r>
-              <a:t>Lyre Build Packet  |  Slide 5 of 13</a:t>
-            </a:r>
-          </a:p>
-        </p:txBody>
-      </p:sp>
-    </p:spTree>
-  </p:cSld>
-  <p:clrMapOvr>
-    <a:masterClrMapping/>
-  </p:clrMapOvr>
-</p:sld>
-</file>
-
-<file path=ppt/slides/slide6.xml><?xml version="1.0" encoding="utf-8"?>
-<p:sld xmlns:a="http://schemas.openxmlformats.org/drawingml/2006/main" xmlns:p="http://schemas.openxmlformats.org/presentationml/2006/main" xmlns:r="http://schemas.openxmlformats.org/officeDocument/2006/relationships">
-  <p:cSld>
-    <p:spTree>
-      <p:nvGrpSpPr>
-        <p:cNvPr id="1" name=""/>
-        <p:cNvGrpSpPr/>
-        <p:nvPr/>
-      </p:nvGrpSpPr>
-      <p:grpSpPr/>
-      <p:sp>
-        <p:nvSpPr>
-          <p:cNvPr id="2" name="Rectangle 1"/>
-          <p:cNvSpPr/>
-          <p:nvPr/>
-        </p:nvSpPr>
-        <p:spPr>
-          <a:xfrm>
-            <a:off x="0" y="0"/>
-            <a:ext cx="12191695" cy="411480"/>
-          </a:xfrm>
-          <a:prstGeom prst="rect">
-            <a:avLst/>
-          </a:prstGeom>
-          <a:solidFill>
-            <a:srgbClr val="1F3A68"/>
-          </a:solidFill>
-          <a:ln>
-            <a:noFill/>
-          </a:ln>
-        </p:spPr>
-        <p:style>
-          <a:lnRef idx="1">
-            <a:schemeClr val="accent1"/>
-          </a:lnRef>
-          <a:fillRef idx="3">
-            <a:schemeClr val="accent1"/>
-          </a:fillRef>
-          <a:effectRef idx="2">
-            <a:schemeClr val="accent1"/>
-          </a:effectRef>
-          <a:fontRef idx="minor">
-            <a:schemeClr val="lt1"/>
-          </a:fontRef>
-        </p:style>
-        <p:txBody>
-          <a:bodyPr rtlCol="0" anchor="ctr"/>
-          <a:lstStyle/>
-          <a:p>
-            <a:pPr algn="ctr"/>
-          </a:p>
-        </p:txBody>
-      </p:sp>
-      <p:sp>
-        <p:nvSpPr>
-          <p:cNvPr id="3" name="TextBox 2"/>
-          <p:cNvSpPr txBox="1"/>
-          <p:nvPr/>
-        </p:nvSpPr>
-        <p:spPr>
-          <a:xfrm>
-            <a:off x="457200" y="548640"/>
-            <a:ext cx="11247120" cy="914400"/>
-          </a:xfrm>
-          <a:prstGeom prst="rect">
-            <a:avLst/>
-          </a:prstGeom>
-          <a:noFill/>
-        </p:spPr>
-        <p:txBody>
-          <a:bodyPr wrap="square">
-            <a:spAutoFit/>
-          </a:bodyPr>
-          <a:lstStyle/>
-          <a:p>
-            <a:pPr>
-              <a:defRPr sz="3000" b="1">
-                <a:solidFill>
-                  <a:srgbClr val="1F3A68"/>
-                </a:solidFill>
-              </a:defRPr>
-            </a:pPr>
-            <a:r>
-              <a:t>Build Workflow</a:t>
-            </a:r>
-          </a:p>
-        </p:txBody>
-      </p:sp>
-      <p:sp>
-        <p:nvSpPr>
-          <p:cNvPr id="4" name="TextBox 3"/>
-          <p:cNvSpPr txBox="1"/>
-          <p:nvPr/>
-        </p:nvSpPr>
-        <p:spPr>
-          <a:xfrm>
-            <a:off x="457200" y="1463040"/>
-            <a:ext cx="11247120" cy="4754880"/>
-          </a:xfrm>
-          <a:prstGeom prst="rect">
-            <a:avLst/>
-          </a:prstGeom>
-          <a:noFill/>
-        </p:spPr>
-        <p:txBody>
-          <a:bodyPr wrap="square">
-            <a:spAutoFit/>
-          </a:bodyPr>
-          <a:lstStyle/>
-          <a:p>
-            <a:pPr>
-              <a:spcAft>
-                <a:spcPts val="800"/>
-              </a:spcAft>
-              <a:defRPr sz="2000">
-                <a:solidFill>
-                  <a:srgbClr val="445577"/>
-                </a:solidFill>
-              </a:defRPr>
-            </a:pPr>
-            <a:r>
-              <a:t>• Design and assumptions</a:t>
-            </a:r>
-          </a:p>
-          <a:p>
-            <a:pPr>
-              <a:spcAft>
-                <a:spcPts val="800"/>
-              </a:spcAft>
-              <a:defRPr sz="2000">
-                <a:solidFill>
-                  <a:srgbClr val="445577"/>
-                </a:solidFill>
-              </a:defRPr>
-            </a:pPr>
-            <a:r>
-              <a:t>• Source materials and hardware</a:t>
-            </a:r>
-          </a:p>
-          <a:p>
-            <a:pPr>
-              <a:spcAft>
-                <a:spcPts val="800"/>
-              </a:spcAft>
-              <a:defRPr sz="2000">
-                <a:solidFill>
-                  <a:srgbClr val="445577"/>
-                </a:solidFill>
-              </a:defRPr>
-            </a:pPr>
-            <a:r>
-              <a:t>• Prepare stock, fixtures, and CNC/laser/lathe setup</a:t>
-            </a:r>
-          </a:p>
-          <a:p>
-            <a:pPr>
-              <a:spcAft>
-                <a:spcPts val="800"/>
-              </a:spcAft>
-              <a:defRPr sz="2000">
-                <a:solidFill>
-                  <a:srgbClr val="445577"/>
-                </a:solidFill>
-              </a:defRPr>
-            </a:pPr>
-            <a:r>
-              <a:t>• Assemble, tune, finish, and validate</a:t>
-            </a:r>
-          </a:p>
-        </p:txBody>
-      </p:sp>
-      <p:sp>
-        <p:nvSpPr>
-          <p:cNvPr id="5" name="TextBox 4"/>
-          <p:cNvSpPr txBox="1"/>
-          <p:nvPr/>
-        </p:nvSpPr>
-        <p:spPr>
-          <a:xfrm>
-            <a:off x="457200" y="6446520"/>
-            <a:ext cx="11247120" cy="274320"/>
-          </a:xfrm>
-          <a:prstGeom prst="rect">
-            <a:avLst/>
-          </a:prstGeom>
-          <a:noFill/>
-        </p:spPr>
-        <p:txBody>
-          <a:bodyPr wrap="none">
-            <a:spAutoFit/>
-          </a:bodyPr>
-          <a:lstStyle/>
-          <a:p>
-            <a:pPr>
-              <a:defRPr sz="1000">
-                <a:solidFill>
-                  <a:srgbClr val="445577"/>
-                </a:solidFill>
-              </a:defRPr>
-            </a:pPr>
-            <a:r>
-              <a:t>Lyre Build Packet  |  Slide 6 of 13</a:t>
-            </a:r>
-          </a:p>
-        </p:txBody>
-      </p:sp>
-    </p:spTree>
-  </p:cSld>
-  <p:clrMapOvr>
-    <a:masterClrMapping/>
-  </p:clrMapOvr>
-</p:sld>
-</file>
-
-<file path=ppt/slides/slide7.xml><?xml version="1.0" encoding="utf-8"?>
-<p:sld xmlns:a="http://schemas.openxmlformats.org/drawingml/2006/main" xmlns:p="http://schemas.openxmlformats.org/presentationml/2006/main" xmlns:r="http://schemas.openxmlformats.org/officeDocument/2006/relationships">
-  <p:cSld>
-    <p:spTree>
-      <p:nvGrpSpPr>
-        <p:cNvPr id="1" name=""/>
-        <p:cNvGrpSpPr/>
-        <p:nvPr/>
-      </p:nvGrpSpPr>
-      <p:grpSpPr/>
-      <p:sp>
-        <p:nvSpPr>
-          <p:cNvPr id="2" name="Rectangle 1"/>
-          <p:cNvSpPr/>
-          <p:nvPr/>
-        </p:nvSpPr>
-        <p:spPr>
-          <a:xfrm>
-            <a:off x="0" y="0"/>
-            <a:ext cx="12191695" cy="411480"/>
-          </a:xfrm>
-          <a:prstGeom prst="rect">
-            <a:avLst/>
-          </a:prstGeom>
-          <a:solidFill>
-            <a:srgbClr val="1F3A68"/>
-          </a:solidFill>
-          <a:ln>
-            <a:noFill/>
-          </a:ln>
-        </p:spPr>
-        <p:style>
-          <a:lnRef idx="1">
-            <a:schemeClr val="accent1"/>
-          </a:lnRef>
-          <a:fillRef idx="3">
-            <a:schemeClr val="accent1"/>
-          </a:fillRef>
-          <a:effectRef idx="2">
-            <a:schemeClr val="accent1"/>
-          </a:effectRef>
-          <a:fontRef idx="minor">
-            <a:schemeClr val="lt1"/>
-          </a:fontRef>
-        </p:style>
-        <p:txBody>
-          <a:bodyPr rtlCol="0" anchor="ctr"/>
-          <a:lstStyle/>
-          <a:p>
-            <a:pPr algn="ctr"/>
-          </a:p>
-        </p:txBody>
-      </p:sp>
-      <p:sp>
-        <p:nvSpPr>
-          <p:cNvPr id="3" name="TextBox 2"/>
-          <p:cNvSpPr txBox="1"/>
-          <p:nvPr/>
-        </p:nvSpPr>
-        <p:spPr>
-          <a:xfrm>
-            <a:off x="457200" y="548640"/>
-            <a:ext cx="11247120" cy="914400"/>
-          </a:xfrm>
-          <a:prstGeom prst="rect">
-            <a:avLst/>
-          </a:prstGeom>
-          <a:noFill/>
-        </p:spPr>
-        <p:txBody>
-          <a:bodyPr wrap="square">
-            <a:spAutoFit/>
-          </a:bodyPr>
-          <a:lstStyle/>
-          <a:p>
-            <a:pPr>
-              <a:defRPr sz="3000" b="1">
-                <a:solidFill>
-                  <a:srgbClr val="1F3A68"/>
-                </a:solidFill>
-              </a:defRPr>
-            </a:pPr>
-            <a:r>
-              <a:t>Sourcing And BOM</a:t>
-            </a:r>
-          </a:p>
-        </p:txBody>
-      </p:sp>
-      <p:sp>
-        <p:nvSpPr>
-          <p:cNvPr id="4" name="TextBox 3"/>
-          <p:cNvSpPr txBox="1"/>
-          <p:nvPr/>
-        </p:nvSpPr>
-        <p:spPr>
-          <a:xfrm>
-            <a:off x="457200" y="1463040"/>
-            <a:ext cx="11247120" cy="4754880"/>
-          </a:xfrm>
-          <a:prstGeom prst="rect">
-            <a:avLst/>
-          </a:prstGeom>
-          <a:noFill/>
-        </p:spPr>
-        <p:txBody>
-          <a:bodyPr wrap="square">
-            <a:spAutoFit/>
-          </a:bodyPr>
-          <a:lstStyle/>
-          <a:p>
-            <a:pPr>
-              <a:spcAft>
-                <a:spcPts val="800"/>
-              </a:spcAft>
-              <a:defRPr sz="2000">
-                <a:solidFill>
-                  <a:srgbClr val="445577"/>
-                </a:solidFill>
-              </a:defRPr>
-            </a:pPr>
-            <a:r>
-              <a:t>• BOM gives part categories and drawing references.</a:t>
-            </a:r>
-          </a:p>
-          <a:p>
-            <a:pPr>
-              <a:spcAft>
-                <a:spcPts val="800"/>
-              </a:spcAft>
-              <a:defRPr sz="2000">
-                <a:solidFill>
-                  <a:srgbClr val="445577"/>
-                </a:solidFill>
-              </a:defRPr>
-            </a:pPr>
-            <a:r>
-              <a:t>• Sourcing tracks search terms, supplier candidates, price/date, lead time, substitutions.</a:t>
-            </a:r>
-          </a:p>
-          <a:p>
-            <a:pPr>
-              <a:spcAft>
-                <a:spcPts val="800"/>
-              </a:spcAft>
-              <a:defRPr sz="2000">
-                <a:solidFill>
-                  <a:srgbClr val="445577"/>
-                </a:solidFill>
-              </a:defRPr>
-            </a:pPr>
-            <a:r>
-              <a:t>• Visual BOM brief turns the parts list into a presentation-ready image board.</a:t>
-            </a:r>
-          </a:p>
-        </p:txBody>
-      </p:sp>
-      <p:sp>
-        <p:nvSpPr>
-          <p:cNvPr id="5" name="TextBox 4"/>
-          <p:cNvSpPr txBox="1"/>
-          <p:nvPr/>
-        </p:nvSpPr>
-        <p:spPr>
-          <a:xfrm>
-            <a:off x="457200" y="6446520"/>
-            <a:ext cx="11247120" cy="274320"/>
-          </a:xfrm>
-          <a:prstGeom prst="rect">
-            <a:avLst/>
-          </a:prstGeom>
-          <a:noFill/>
-        </p:spPr>
-        <p:txBody>
-          <a:bodyPr wrap="none">
-            <a:spAutoFit/>
-          </a:bodyPr>
-          <a:lstStyle/>
-          <a:p>
-            <a:pPr>
-              <a:defRPr sz="1000">
-                <a:solidFill>
-                  <a:srgbClr val="445577"/>
-                </a:solidFill>
-              </a:defRPr>
-            </a:pPr>
-            <a:r>
-              <a:t>Lyre Build Packet  |  Slide 7 of 13</a:t>
-            </a:r>
-          </a:p>
-        </p:txBody>
-      </p:sp>
-    </p:spTree>
-  </p:cSld>
-  <p:clrMapOvr>
-    <a:masterClrMapping/>
-  </p:clrMapOvr>
-</p:sld>
-</file>
-
-<file path=ppt/slides/slide8.xml><?xml version="1.0" encoding="utf-8"?>
-<p:sld xmlns:a="http://schemas.openxmlformats.org/drawingml/2006/main" xmlns:p="http://schemas.openxmlformats.org/presentationml/2006/main" xmlns:r="http://schemas.openxmlformats.org/officeDocument/2006/relationships">
-  <p:cSld>
-    <p:spTree>
-      <p:nvGrpSpPr>
-        <p:cNvPr id="1" name=""/>
-        <p:cNvGrpSpPr/>
-        <p:nvPr/>
-      </p:nvGrpSpPr>
-      <p:grpSpPr/>
-      <p:sp>
-        <p:nvSpPr>
-          <p:cNvPr id="2" name="Rectangle 1"/>
-          <p:cNvSpPr/>
-          <p:nvPr/>
-        </p:nvSpPr>
-        <p:spPr>
-          <a:xfrm>
-            <a:off x="0" y="0"/>
-            <a:ext cx="12191695" cy="411480"/>
-          </a:xfrm>
-          <a:prstGeom prst="rect">
-            <a:avLst/>
-          </a:prstGeom>
-          <a:solidFill>
-            <a:srgbClr val="1F3A68"/>
-          </a:solidFill>
-          <a:ln>
-            <a:noFill/>
-          </a:ln>
-        </p:spPr>
-        <p:style>
-          <a:lnRef idx="1">
-            <a:schemeClr val="accent1"/>
-          </a:lnRef>
-          <a:fillRef idx="3">
-            <a:schemeClr val="accent1"/>
-          </a:fillRef>
-          <a:effectRef idx="2">
-            <a:schemeClr val="accent1"/>
-          </a:effectRef>
-          <a:fontRef idx="minor">
-            <a:schemeClr val="lt1"/>
-          </a:fontRef>
-        </p:style>
-        <p:txBody>
-          <a:bodyPr rtlCol="0" anchor="ctr"/>
-          <a:lstStyle/>
-          <a:p>
-            <a:pPr algn="ctr"/>
-          </a:p>
-        </p:txBody>
-      </p:sp>
-      <p:sp>
-        <p:nvSpPr>
-          <p:cNvPr id="3" name="TextBox 2"/>
-          <p:cNvSpPr txBox="1"/>
-          <p:nvPr/>
-        </p:nvSpPr>
-        <p:spPr>
-          <a:xfrm>
-            <a:off x="457200" y="548640"/>
-            <a:ext cx="11247120" cy="914400"/>
-          </a:xfrm>
-          <a:prstGeom prst="rect">
-            <a:avLst/>
-          </a:prstGeom>
-          <a:noFill/>
-        </p:spPr>
-        <p:txBody>
-          <a:bodyPr wrap="square">
-            <a:spAutoFit/>
-          </a:bodyPr>
-          <a:lstStyle/>
-          <a:p>
-            <a:pPr>
-              <a:defRPr sz="3000" b="1">
-                <a:solidFill>
-                  <a:srgbClr val="1F3A68"/>
-                </a:solidFill>
-              </a:defRPr>
-            </a:pPr>
-            <a:r>
-              <a:t>Shop Packet</a:t>
-            </a:r>
-          </a:p>
-        </p:txBody>
-      </p:sp>
-      <p:sp>
-        <p:nvSpPr>
-          <p:cNvPr id="4" name="TextBox 3"/>
-          <p:cNvSpPr txBox="1"/>
-          <p:nvPr/>
-        </p:nvSpPr>
-        <p:spPr>
-          <a:xfrm>
-            <a:off x="457200" y="1463040"/>
-            <a:ext cx="11247120" cy="4754880"/>
-          </a:xfrm>
-          <a:prstGeom prst="rect">
-            <a:avLst/>
-          </a:prstGeom>
-          <a:noFill/>
-        </p:spPr>
-        <p:txBody>
-          <a:bodyPr wrap="square">
-            <a:spAutoFit/>
-          </a:bodyPr>
-          <a:lstStyle/>
-          <a:p>
-            <a:pPr>
-              <a:spcAft>
-                <a:spcPts val="800"/>
-              </a:spcAft>
-              <a:defRPr sz="2000">
-                <a:solidFill>
-                  <a:srgbClr val="445577"/>
-                </a:solidFill>
-              </a:defRPr>
-            </a:pPr>
-            <a:r>
-              <a:t>• Cut list for lumber/sheet/blank planning.</a:t>
-            </a:r>
-          </a:p>
-          <a:p>
-            <a:pPr>
-              <a:spcAft>
-                <a:spcPts val="800"/>
-              </a:spcAft>
-              <a:defRPr sz="2000">
-                <a:solidFill>
-                  <a:srgbClr val="445577"/>
-                </a:solidFill>
-              </a:defRPr>
-            </a:pPr>
-            <a:r>
-              <a:t>• Assembly manual for away-from-keyboard work.</a:t>
-            </a:r>
-          </a:p>
-          <a:p>
-            <a:pPr>
-              <a:spcAft>
-                <a:spcPts val="800"/>
-              </a:spcAft>
-              <a:defRPr sz="2000">
-                <a:solidFill>
-                  <a:srgbClr val="445577"/>
-                </a:solidFill>
-              </a:defRPr>
-            </a:pPr>
-            <a:r>
-              <a:t>• Validation sheet for measured dimensions, tuning, pass/fail checks.</a:t>
-            </a:r>
-          </a:p>
-        </p:txBody>
-      </p:sp>
-      <p:sp>
-        <p:nvSpPr>
-          <p:cNvPr id="5" name="TextBox 4"/>
-          <p:cNvSpPr txBox="1"/>
-          <p:nvPr/>
-        </p:nvSpPr>
-        <p:spPr>
-          <a:xfrm>
-            <a:off x="457200" y="6446520"/>
-            <a:ext cx="11247120" cy="274320"/>
-          </a:xfrm>
-          <a:prstGeom prst="rect">
-            <a:avLst/>
-          </a:prstGeom>
-          <a:noFill/>
-        </p:spPr>
-        <p:txBody>
-          <a:bodyPr wrap="none">
-            <a:spAutoFit/>
-          </a:bodyPr>
-          <a:lstStyle/>
-          <a:p>
-            <a:pPr>
-              <a:defRPr sz="1000">
-                <a:solidFill>
-                  <a:srgbClr val="445577"/>
-                </a:solidFill>
-              </a:defRPr>
-            </a:pPr>
-            <a:r>
-              <a:t>Lyre Build Packet  |  Slide 8 of 13</a:t>
-            </a:r>
-          </a:p>
-        </p:txBody>
-      </p:sp>
-    </p:spTree>
-  </p:cSld>
-  <p:clrMapOvr>
-    <a:masterClrMapping/>
-  </p:clrMapOvr>
-</p:sld>
-</file>
-
-<file path=ppt/slides/slide9.xml><?xml version="1.0" encoding="utf-8"?>
-<p:sld xmlns:a="http://schemas.openxmlformats.org/drawingml/2006/main" xmlns:p="http://schemas.openxmlformats.org/presentationml/2006/main" xmlns:r="http://schemas.openxmlformats.org/officeDocument/2006/relationships">
-  <p:cSld>
-    <p:spTree>
-      <p:nvGrpSpPr>
-        <p:cNvPr id="1" name=""/>
-        <p:cNvGrpSpPr/>
-        <p:nvPr/>
-      </p:nvGrpSpPr>
-      <p:grpSpPr/>
-      <p:sp>
-        <p:nvSpPr>
-          <p:cNvPr id="2" name="Rectangle 1"/>
-          <p:cNvSpPr/>
-          <p:nvPr/>
-        </p:nvSpPr>
-        <p:spPr>
-          <a:xfrm>
-            <a:off x="0" y="0"/>
-            <a:ext cx="12191695" cy="411480"/>
-          </a:xfrm>
-          <a:prstGeom prst="rect">
-            <a:avLst/>
-          </a:prstGeom>
-          <a:solidFill>
-            <a:srgbClr val="1F3A68"/>
-          </a:solidFill>
-          <a:ln>
-            <a:noFill/>
-          </a:ln>
-        </p:spPr>
-        <p:style>
-          <a:lnRef idx="1">
-            <a:schemeClr val="accent1"/>
-          </a:lnRef>
-          <a:fillRef idx="3">
-            <a:schemeClr val="accent1"/>
-          </a:fillRef>
-          <a:effectRef idx="2">
-            <a:schemeClr val="accent1"/>
-          </a:effectRef>
-          <a:fontRef idx="minor">
-            <a:schemeClr val="lt1"/>
-          </a:fontRef>
-        </p:style>
-        <p:txBody>
-          <a:bodyPr rtlCol="0" anchor="ctr"/>
-          <a:lstStyle/>
-          <a:p>
-            <a:pPr algn="ctr"/>
-          </a:p>
-        </p:txBody>
-      </p:sp>
-      <p:sp>
-        <p:nvSpPr>
-          <p:cNvPr id="3" name="TextBox 2"/>
-          <p:cNvSpPr txBox="1"/>
-          <p:nvPr/>
-        </p:nvSpPr>
-        <p:spPr>
-          <a:xfrm>
-            <a:off x="457200" y="548640"/>
-            <a:ext cx="11247120" cy="914400"/>
-          </a:xfrm>
-          <a:prstGeom prst="rect">
-            <a:avLst/>
-          </a:prstGeom>
-          <a:noFill/>
-        </p:spPr>
-        <p:txBody>
-          <a:bodyPr wrap="square">
-            <a:spAutoFit/>
-          </a:bodyPr>
-          <a:lstStyle/>
-          <a:p>
-            <a:pPr>
-              <a:defRPr sz="3000" b="1">
-                <a:solidFill>
-                  <a:srgbClr val="1F3A68"/>
-                </a:solidFill>
-              </a:defRPr>
-            </a:pPr>
-            <a:r>
-              <a:t>Drawings, CAD, CNC</a:t>
-            </a:r>
-          </a:p>
-        </p:txBody>
-      </p:sp>
-      <p:sp>
-        <p:nvSpPr>
-          <p:cNvPr id="4" name="TextBox 3"/>
-          <p:cNvSpPr txBox="1"/>
-          <p:nvPr/>
-        </p:nvSpPr>
-        <p:spPr>
-          <a:xfrm>
-            <a:off x="457200" y="1463040"/>
-            <a:ext cx="11247120" cy="4754880"/>
-          </a:xfrm>
-          <a:prstGeom prst="rect">
-            <a:avLst/>
-          </a:prstGeom>
-          <a:noFill/>
-        </p:spPr>
-        <p:txBody>
-          <a:bodyPr wrap="square">
-            <a:spAutoFit/>
-          </a:bodyPr>
-          <a:lstStyle/>
-          <a:p>
-            <a:pPr>
-              <a:spcAft>
-                <a:spcPts val="800"/>
-              </a:spcAft>
-              <a:defRPr sz="2000">
-                <a:solidFill>
-                  <a:srgbClr val="445577"/>
-                </a:solidFill>
-              </a:defRPr>
-            </a:pPr>
-            <a:r>
-              <a:t>• drawing-brief.md defines required views, dimensions, datums, sketch intent.</a:t>
-            </a:r>
-          </a:p>
-          <a:p>
-            <a:pPr>
-              <a:spcAft>
-                <a:spcPts val="800"/>
-              </a:spcAft>
-              <a:defRPr sz="2000">
-                <a:solidFill>
-                  <a:srgbClr val="445577"/>
-                </a:solidFill>
-              </a:defRPr>
-            </a:pPr>
-            <a:r>
-              <a:t>• cad/ holds models and design tables.</a:t>
-            </a:r>
-          </a:p>
-          <a:p>
-            <a:pPr>
-              <a:spcAft>
-                <a:spcPts val="800"/>
-              </a:spcAft>
-              <a:defRPr sz="2000">
-                <a:solidFill>
-                  <a:srgbClr val="445577"/>
-                </a:solidFill>
-              </a:defRPr>
-            </a:pPr>
-            <a:r>
-              <a:t>• cnc/ holds CAM, toolpaths, setup sheets, dry-run notes.</a:t>
-            </a:r>
-          </a:p>
-          <a:p>
-            <a:pPr>
-              <a:spcAft>
-                <a:spcPts val="800"/>
-              </a:spcAft>
-              <a:defRPr sz="2000">
-                <a:solidFill>
-                  <a:srgbClr val="445577"/>
-                </a:solidFill>
-              </a:defRPr>
-            </a:pPr>
-            <a:r>
-              <a:t>• drawings/ holds PDFs, SVGs, DXFs, drawing exports.</a:t>
-            </a:r>
-          </a:p>
-        </p:txBody>
-      </p:sp>
-      <p:sp>
-        <p:nvSpPr>
-          <p:cNvPr id="5" name="TextBox 4"/>
-          <p:cNvSpPr txBox="1"/>
-          <p:nvPr/>
-        </p:nvSpPr>
-        <p:spPr>
-          <a:xfrm>
-            <a:off x="457200" y="6446520"/>
-            <a:ext cx="11247120" cy="274320"/>
-          </a:xfrm>
-          <a:prstGeom prst="rect">
-            <a:avLst/>
-          </a:prstGeom>
-          <a:noFill/>
-        </p:spPr>
-        <p:txBody>
-          <a:bodyPr wrap="none">
-            <a:spAutoFit/>
-          </a:bodyPr>
-          <a:lstStyle/>
-          <a:p>
-            <a:pPr>
-              <a:defRPr sz="1000">
-                <a:solidFill>
-                  <a:srgbClr val="445577"/>
-                </a:solidFill>
-              </a:defRPr>
-            </a:pPr>
-            <a:r>
-              <a:t>Lyre Build Packet  |  Slide 9 of 13</a:t>
+              <a:t>Record first pitch-up log and prototype photos before readiness promotion</a:t>
             </a:r>
           </a:p>
         </p:txBody>

</xml_diff>